<commit_message>
Update ROC curve evaluation cell in Code without Output notebooks and sync paper document
</commit_message>
<xml_diff>
--- a/MST1/Fraud_BERT_Research_Paper_Presentation.pptx
+++ b/MST1/Fraud_BERT_Research_Paper_Presentation.pptx
@@ -7,23 +7,23 @@
     <p:sldMasterId id="2147483686" r:id="rId3"/>
   </p:sldMasterIdLst>
   <p:notesMasterIdLst>
-    <p:notesMasterId r:id="rId14"/>
+    <p:notesMasterId r:id="rId15"/>
   </p:notesMasterIdLst>
   <p:handoutMasterIdLst>
-    <p:handoutMasterId r:id="rId15"/>
+    <p:handoutMasterId r:id="rId16"/>
   </p:handoutMasterIdLst>
   <p:sldIdLst>
     <p:sldId id="277" r:id="rId4"/>
     <p:sldId id="400" r:id="rId5"/>
-    <p:sldId id="424" r:id="rId20"/>
-    <p:sldId id="408" r:id="rId6"/>
-    <p:sldId id="401" r:id="rId7"/>
-    <p:sldId id="409" r:id="rId8"/>
-    <p:sldId id="420" r:id="rId9"/>
-    <p:sldId id="421" r:id="rId10"/>
-    <p:sldId id="422" r:id="rId11"/>
-    <p:sldId id="423" r:id="rId12"/>
-    <p:sldId id="419" r:id="rId13"/>
+    <p:sldId id="424" r:id="rId6"/>
+    <p:sldId id="408" r:id="rId7"/>
+    <p:sldId id="401" r:id="rId8"/>
+    <p:sldId id="421" r:id="rId9"/>
+    <p:sldId id="409" r:id="rId10"/>
+    <p:sldId id="420" r:id="rId11"/>
+    <p:sldId id="422" r:id="rId12"/>
+    <p:sldId id="423" r:id="rId13"/>
+    <p:sldId id="419" r:id="rId14"/>
   </p:sldIdLst>
   <p:sldSz cx="12192000" cy="6858000"/>
   <p:notesSz cx="6858000" cy="9144000"/>
@@ -238,7 +238,7 @@
             <a:fld id="{92CDA8E9-9948-4BC7-A1DE-415AE6D34228}" type="datetimeFigureOut">
               <a:rPr lang="en-US" smtClean="0"/>
               <a:pPr/>
-              <a:t>4/28/2026</a:t>
+              <a:t>9/1/2026</a:t>
             </a:fld>
             <a:endParaRPr lang="en-US" dirty="0"/>
           </a:p>
@@ -406,7 +406,7 @@
             <a:fld id="{95A4AE53-78AB-4E30-A376-70F5FA87A326}" type="datetimeFigureOut">
               <a:rPr lang="en-US" smtClean="0"/>
               <a:pPr/>
-              <a:t>4/28/2026</a:t>
+              <a:t>9/1/2026</a:t>
             </a:fld>
             <a:endParaRPr lang="en-US" dirty="0"/>
           </a:p>
@@ -13490,6 +13490,602 @@
       </p:grpSpPr>
       <p:sp>
         <p:nvSpPr>
+          <p:cNvPr id="2" name="Title 1">
+            <a:extLst>
+              <a:ext uri="{FF2B5EF4-FFF2-40B4-BE49-F238E27FC236}">
+                <a16:creationId xmlns:a16="http://schemas.microsoft.com/office/drawing/2014/main" id="{636E7A3C-C78E-3208-1872-119F59D69BA3}"/>
+              </a:ext>
+            </a:extLst>
+          </p:cNvPr>
+          <p:cNvSpPr>
+            <a:spLocks noGrp="1"/>
+          </p:cNvSpPr>
+          <p:nvPr>
+            <p:ph type="title"/>
+          </p:nvPr>
+        </p:nvSpPr>
+        <p:spPr>
+          <a:xfrm>
+            <a:off x="838200" y="365125"/>
+            <a:ext cx="10515600" cy="690677"/>
+          </a:xfrm>
+        </p:spPr>
+        <p:txBody>
+          <a:bodyPr>
+            <a:normAutofit/>
+          </a:bodyPr>
+          <a:lstStyle/>
+          <a:p>
+            <a:r>
+              <a:rPr sz="3600" b="1" i="0">
+                <a:solidFill>
+                  <a:srgbClr val="102C57"/>
+                </a:solidFill>
+                <a:latin typeface="Calibri"/>
+              </a:rPr>
+              <a:t>Bibliography or References</a:t>
+            </a:r>
+          </a:p>
+        </p:txBody>
+      </p:sp>
+      <p:sp>
+        <p:nvSpPr>
+          <p:cNvPr id="3" name="Content Placeholder 2">
+            <a:extLst>
+              <a:ext uri="{FF2B5EF4-FFF2-40B4-BE49-F238E27FC236}">
+                <a16:creationId xmlns:a16="http://schemas.microsoft.com/office/drawing/2014/main" id="{5C3A669F-24DE-9251-47BD-73C228B1EC1C}"/>
+              </a:ext>
+            </a:extLst>
+          </p:cNvPr>
+          <p:cNvSpPr>
+            <a:spLocks noGrp="1"/>
+          </p:cNvSpPr>
+          <p:nvPr>
+            <p:ph idx="1"/>
+          </p:nvPr>
+        </p:nvSpPr>
+        <p:spPr>
+          <a:xfrm>
+            <a:off x="838200" y="1354283"/>
+            <a:ext cx="10515600" cy="5138591"/>
+          </a:xfrm>
+        </p:spPr>
+        <p:txBody>
+          <a:bodyPr>
+            <a:normAutofit/>
+          </a:bodyPr>
+          <a:lstStyle/>
+          <a:p>
+            <a:pPr marL="0" indent="0" algn="just">
+              <a:lnSpc>
+                <a:spcPct val="115000"/>
+              </a:lnSpc>
+              <a:spcAft>
+                <a:spcPts val="800"/>
+              </a:spcAft>
+              <a:buNone/>
+            </a:pPr>
+            <a:r>
+              <a:rPr sz="1700" b="1" i="0" dirty="0">
+                <a:solidFill>
+                  <a:srgbClr val="102C57"/>
+                </a:solidFill>
+                <a:latin typeface="Calibri"/>
+              </a:rPr>
+              <a:t>[1] </a:t>
+            </a:r>
+            <a:r>
+              <a:rPr sz="1700" b="0" i="0" dirty="0">
+                <a:solidFill>
+                  <a:srgbClr val="323232"/>
+                </a:solidFill>
+                <a:latin typeface="Calibri"/>
+              </a:rPr>
+              <a:t>Taneja, K., </a:t>
+            </a:r>
+            <a:r>
+              <a:rPr sz="1700" b="0" i="0" dirty="0" err="1">
+                <a:solidFill>
+                  <a:srgbClr val="323232"/>
+                </a:solidFill>
+                <a:latin typeface="Calibri"/>
+              </a:rPr>
+              <a:t>Vashishtha</a:t>
+            </a:r>
+            <a:r>
+              <a:rPr sz="1700" b="0" i="0" dirty="0">
+                <a:solidFill>
+                  <a:srgbClr val="323232"/>
+                </a:solidFill>
+                <a:latin typeface="Calibri"/>
+              </a:rPr>
+              <a:t>, J., &amp; </a:t>
+            </a:r>
+            <a:r>
+              <a:rPr sz="1700" b="0" i="0" dirty="0" err="1">
+                <a:solidFill>
+                  <a:srgbClr val="323232"/>
+                </a:solidFill>
+                <a:latin typeface="Calibri"/>
+              </a:rPr>
+              <a:t>Ratnoo</a:t>
+            </a:r>
+            <a:r>
+              <a:rPr sz="1700" b="0" i="0" dirty="0">
+                <a:solidFill>
+                  <a:srgbClr val="323232"/>
+                </a:solidFill>
+                <a:latin typeface="Calibri"/>
+              </a:rPr>
+              <a:t>, S. (2025). Fraud-BERT: Transformer based context aware online recruitment fraud detection. </a:t>
+            </a:r>
+            <a:r>
+              <a:rPr sz="1700" b="0" i="1" dirty="0">
+                <a:solidFill>
+                  <a:srgbClr val="323232"/>
+                </a:solidFill>
+                <a:latin typeface="Calibri"/>
+              </a:rPr>
+              <a:t>Discover Computing</a:t>
+            </a:r>
+            <a:r>
+              <a:rPr sz="1700" b="0" i="0" dirty="0">
+                <a:solidFill>
+                  <a:srgbClr val="323232"/>
+                </a:solidFill>
+                <a:latin typeface="Calibri"/>
+              </a:rPr>
+              <a:t>, </a:t>
+            </a:r>
+            <a:r>
+              <a:rPr sz="1700" b="0" i="1" dirty="0">
+                <a:solidFill>
+                  <a:srgbClr val="323232"/>
+                </a:solidFill>
+                <a:latin typeface="Calibri"/>
+              </a:rPr>
+              <a:t>28</a:t>
+            </a:r>
+            <a:r>
+              <a:rPr sz="1700" b="0" i="0" dirty="0">
+                <a:solidFill>
+                  <a:srgbClr val="323232"/>
+                </a:solidFill>
+                <a:latin typeface="Calibri"/>
+              </a:rPr>
+              <a:t>(9), 1–16.</a:t>
+            </a:r>
+            <a:r>
+              <a:rPr sz="1700" b="0" i="0" dirty="0">
+                <a:solidFill>
+                  <a:srgbClr val="0066CC"/>
+                </a:solidFill>
+                <a:latin typeface="Calibri"/>
+              </a:rPr>
+              <a:t> https://doi.org/10.1007/s44425-025-00109-x</a:t>
+            </a:r>
+          </a:p>
+          <a:p>
+            <a:pPr marL="0" indent="0" algn="just">
+              <a:lnSpc>
+                <a:spcPct val="115000"/>
+              </a:lnSpc>
+              <a:spcAft>
+                <a:spcPts val="800"/>
+              </a:spcAft>
+              <a:buNone/>
+            </a:pPr>
+            <a:r>
+              <a:rPr sz="1700" b="1" i="0" dirty="0">
+                <a:solidFill>
+                  <a:srgbClr val="102C57"/>
+                </a:solidFill>
+                <a:latin typeface="Calibri"/>
+              </a:rPr>
+              <a:t>[2] </a:t>
+            </a:r>
+            <a:r>
+              <a:rPr sz="1700" b="0" i="0" dirty="0">
+                <a:solidFill>
+                  <a:srgbClr val="323232"/>
+                </a:solidFill>
+                <a:latin typeface="Calibri"/>
+              </a:rPr>
+              <a:t>Pillai, A. S. (2023). Detecting fake job postings using bidirectional LSTM. </a:t>
+            </a:r>
+            <a:r>
+              <a:rPr sz="1700" b="0" i="1" dirty="0">
+                <a:solidFill>
+                  <a:srgbClr val="323232"/>
+                </a:solidFill>
+                <a:latin typeface="Calibri"/>
+              </a:rPr>
+              <a:t>International Research Journal of Modernization in Engineering Technology and Science</a:t>
+            </a:r>
+            <a:r>
+              <a:rPr sz="1700" b="0" i="0" dirty="0">
+                <a:solidFill>
+                  <a:srgbClr val="323232"/>
+                </a:solidFill>
+                <a:latin typeface="Calibri"/>
+              </a:rPr>
+              <a:t>, </a:t>
+            </a:r>
+            <a:r>
+              <a:rPr sz="1700" b="0" i="1" dirty="0">
+                <a:solidFill>
+                  <a:srgbClr val="323232"/>
+                </a:solidFill>
+                <a:latin typeface="Calibri"/>
+              </a:rPr>
+              <a:t>5</a:t>
+            </a:r>
+            <a:r>
+              <a:rPr sz="1700" b="0" i="0" dirty="0">
+                <a:solidFill>
+                  <a:srgbClr val="323232"/>
+                </a:solidFill>
+                <a:latin typeface="Calibri"/>
+              </a:rPr>
+              <a:t>(3), 3883–3890.</a:t>
+            </a:r>
+            <a:r>
+              <a:rPr sz="1700" b="0" i="0" dirty="0">
+                <a:solidFill>
+                  <a:srgbClr val="0066CC"/>
+                </a:solidFill>
+                <a:latin typeface="Calibri"/>
+              </a:rPr>
+              <a:t> https://doi.org/10.56726/IRJMETS34628</a:t>
+            </a:r>
+          </a:p>
+          <a:p>
+            <a:pPr marL="0" indent="0" algn="just">
+              <a:lnSpc>
+                <a:spcPct val="115000"/>
+              </a:lnSpc>
+              <a:spcAft>
+                <a:spcPts val="800"/>
+              </a:spcAft>
+              <a:buNone/>
+            </a:pPr>
+            <a:r>
+              <a:rPr sz="1700" b="1" i="0" dirty="0">
+                <a:solidFill>
+                  <a:srgbClr val="102C57"/>
+                </a:solidFill>
+                <a:latin typeface="Calibri"/>
+              </a:rPr>
+              <a:t>[3] </a:t>
+            </a:r>
+            <a:r>
+              <a:rPr sz="1700" b="0" i="0" dirty="0">
+                <a:solidFill>
+                  <a:srgbClr val="323232"/>
+                </a:solidFill>
+                <a:latin typeface="Calibri"/>
+              </a:rPr>
+              <a:t>Naudé, M., Adebayo, K. J., &amp; Nanda, R. (2023). A machine learning approach to detecting fraudulent job types. </a:t>
+            </a:r>
+            <a:r>
+              <a:rPr sz="1700" b="0" i="1" dirty="0">
+                <a:solidFill>
+                  <a:srgbClr val="323232"/>
+                </a:solidFill>
+                <a:latin typeface="Calibri"/>
+              </a:rPr>
+              <a:t>AI &amp; SOCIETY</a:t>
+            </a:r>
+            <a:r>
+              <a:rPr sz="1700" b="0" i="0" dirty="0">
+                <a:solidFill>
+                  <a:srgbClr val="323232"/>
+                </a:solidFill>
+                <a:latin typeface="Calibri"/>
+              </a:rPr>
+              <a:t>, </a:t>
+            </a:r>
+            <a:r>
+              <a:rPr sz="1700" b="0" i="1" dirty="0">
+                <a:solidFill>
+                  <a:srgbClr val="323232"/>
+                </a:solidFill>
+                <a:latin typeface="Calibri"/>
+              </a:rPr>
+              <a:t>38</a:t>
+            </a:r>
+            <a:r>
+              <a:rPr sz="1700" b="0" i="0" dirty="0">
+                <a:solidFill>
+                  <a:srgbClr val="323232"/>
+                </a:solidFill>
+                <a:latin typeface="Calibri"/>
+              </a:rPr>
+              <a:t>(3), 1013–1024.</a:t>
+            </a:r>
+            <a:r>
+              <a:rPr sz="1700" b="0" i="0" dirty="0">
+                <a:solidFill>
+                  <a:srgbClr val="0066CC"/>
+                </a:solidFill>
+                <a:latin typeface="Calibri"/>
+              </a:rPr>
+              <a:t> https://doi.org/10.1007/s00146-021-01314-z</a:t>
+            </a:r>
+          </a:p>
+          <a:p>
+            <a:pPr marL="0" indent="0" algn="just">
+              <a:lnSpc>
+                <a:spcPct val="115000"/>
+              </a:lnSpc>
+              <a:spcAft>
+                <a:spcPts val="800"/>
+              </a:spcAft>
+              <a:buNone/>
+            </a:pPr>
+            <a:r>
+              <a:rPr sz="1700" b="1" i="0" dirty="0">
+                <a:solidFill>
+                  <a:srgbClr val="102C57"/>
+                </a:solidFill>
+                <a:latin typeface="Calibri"/>
+              </a:rPr>
+              <a:t>[4] </a:t>
+            </a:r>
+            <a:r>
+              <a:rPr sz="1700" b="0" i="0" dirty="0" err="1">
+                <a:solidFill>
+                  <a:srgbClr val="323232"/>
+                </a:solidFill>
+                <a:latin typeface="Calibri"/>
+              </a:rPr>
+              <a:t>Chiraratanasopha</a:t>
+            </a:r>
+            <a:r>
+              <a:rPr sz="1700" b="0" i="0" dirty="0">
+                <a:solidFill>
+                  <a:srgbClr val="323232"/>
+                </a:solidFill>
+                <a:latin typeface="Calibri"/>
+              </a:rPr>
+              <a:t>, B., &amp; Chay-</a:t>
+            </a:r>
+            <a:r>
+              <a:rPr sz="1700" b="0" i="0" dirty="0" err="1">
+                <a:solidFill>
+                  <a:srgbClr val="323232"/>
+                </a:solidFill>
+                <a:latin typeface="Calibri"/>
+              </a:rPr>
+              <a:t>intr</a:t>
+            </a:r>
+            <a:r>
+              <a:rPr sz="1700" b="0" i="0" dirty="0">
+                <a:solidFill>
+                  <a:srgbClr val="323232"/>
+                </a:solidFill>
+                <a:latin typeface="Calibri"/>
+              </a:rPr>
+              <a:t>, T. (2022). Detecting fraud job recruitment using features reflecting from real-world knowledge of fraud. </a:t>
+            </a:r>
+            <a:r>
+              <a:rPr sz="1700" b="0" i="1" dirty="0">
+                <a:solidFill>
+                  <a:srgbClr val="323232"/>
+                </a:solidFill>
+                <a:latin typeface="Calibri"/>
+              </a:rPr>
+              <a:t>Current Applied Science and Technology</a:t>
+            </a:r>
+            <a:r>
+              <a:rPr sz="1700" b="0" i="0" dirty="0">
+                <a:solidFill>
+                  <a:srgbClr val="323232"/>
+                </a:solidFill>
+                <a:latin typeface="Calibri"/>
+              </a:rPr>
+              <a:t>, </a:t>
+            </a:r>
+            <a:r>
+              <a:rPr sz="1700" b="0" i="1" dirty="0">
+                <a:solidFill>
+                  <a:srgbClr val="323232"/>
+                </a:solidFill>
+                <a:latin typeface="Calibri"/>
+              </a:rPr>
+              <a:t>22</a:t>
+            </a:r>
+            <a:r>
+              <a:rPr sz="1700" b="0" i="0" dirty="0">
+                <a:solidFill>
+                  <a:srgbClr val="323232"/>
+                </a:solidFill>
+                <a:latin typeface="Calibri"/>
+              </a:rPr>
+              <a:t>(6), 1–12.</a:t>
+            </a:r>
+            <a:r>
+              <a:rPr sz="1700" b="0" i="0" dirty="0">
+                <a:solidFill>
+                  <a:srgbClr val="0066CC"/>
+                </a:solidFill>
+                <a:latin typeface="Calibri"/>
+              </a:rPr>
+              <a:t> https://doi.org/10.55003/cast.2022.06.22.015</a:t>
+            </a:r>
+          </a:p>
+          <a:p>
+            <a:pPr marL="0" indent="0" algn="just">
+              <a:lnSpc>
+                <a:spcPct val="115000"/>
+              </a:lnSpc>
+              <a:spcAft>
+                <a:spcPts val="800"/>
+              </a:spcAft>
+              <a:buNone/>
+            </a:pPr>
+            <a:r>
+              <a:rPr sz="1700" b="1" i="0" dirty="0">
+                <a:solidFill>
+                  <a:srgbClr val="102C57"/>
+                </a:solidFill>
+                <a:latin typeface="Calibri"/>
+              </a:rPr>
+              <a:t>[5] </a:t>
+            </a:r>
+            <a:r>
+              <a:rPr sz="1700" b="0" i="0" dirty="0">
+                <a:solidFill>
+                  <a:srgbClr val="323232"/>
+                </a:solidFill>
+                <a:latin typeface="Calibri"/>
+              </a:rPr>
+              <a:t>Varshitha, G., Sowmya, K., </a:t>
+            </a:r>
+            <a:r>
+              <a:rPr sz="1700" b="0" i="0" dirty="0" err="1">
+                <a:solidFill>
+                  <a:srgbClr val="323232"/>
+                </a:solidFill>
+                <a:latin typeface="Calibri"/>
+              </a:rPr>
+              <a:t>Sheshma</a:t>
+            </a:r>
+            <a:r>
+              <a:rPr sz="1700" b="0" i="0" dirty="0">
+                <a:solidFill>
+                  <a:srgbClr val="323232"/>
+                </a:solidFill>
+                <a:latin typeface="Calibri"/>
+              </a:rPr>
+              <a:t>, K., Sowmya, K., &amp; Manikandan, R. A. (2026). Online recruitment fraud detection using deep learning approaches. </a:t>
+            </a:r>
+            <a:r>
+              <a:rPr sz="1700" b="0" i="1" dirty="0">
+                <a:solidFill>
+                  <a:srgbClr val="323232"/>
+                </a:solidFill>
+                <a:latin typeface="Calibri"/>
+              </a:rPr>
+              <a:t>International Journal for Multidisciplinary Research (IJFMR)</a:t>
+            </a:r>
+            <a:r>
+              <a:rPr sz="1700" b="0" i="0" dirty="0">
+                <a:solidFill>
+                  <a:srgbClr val="323232"/>
+                </a:solidFill>
+                <a:latin typeface="Calibri"/>
+              </a:rPr>
+              <a:t>, </a:t>
+            </a:r>
+            <a:r>
+              <a:rPr sz="1700" b="0" i="1" dirty="0">
+                <a:solidFill>
+                  <a:srgbClr val="323232"/>
+                </a:solidFill>
+                <a:latin typeface="Calibri"/>
+              </a:rPr>
+              <a:t>8</a:t>
+            </a:r>
+            <a:r>
+              <a:rPr sz="1700" b="0" i="0" dirty="0">
+                <a:solidFill>
+                  <a:srgbClr val="323232"/>
+                </a:solidFill>
+                <a:latin typeface="Calibri"/>
+              </a:rPr>
+              <a:t>(2), 1–9.</a:t>
+            </a:r>
+            <a:r>
+              <a:rPr sz="1700" b="0" i="0" dirty="0">
+                <a:solidFill>
+                  <a:srgbClr val="0066CC"/>
+                </a:solidFill>
+                <a:latin typeface="Calibri"/>
+              </a:rPr>
+              <a:t> https://doi.org/10.36948/ijfmr.2026.v08i02.14582</a:t>
+            </a:r>
+          </a:p>
+        </p:txBody>
+      </p:sp>
+      <p:sp>
+        <p:nvSpPr>
+          <p:cNvPr id="4" name="Slide Number Placeholder 3">
+            <a:extLst>
+              <a:ext uri="{FF2B5EF4-FFF2-40B4-BE49-F238E27FC236}">
+                <a16:creationId xmlns:a16="http://schemas.microsoft.com/office/drawing/2014/main" id="{904A35CC-DD65-AB1D-D9C1-30BD38C24B0B}"/>
+              </a:ext>
+            </a:extLst>
+          </p:cNvPr>
+          <p:cNvSpPr>
+            <a:spLocks noGrp="1"/>
+          </p:cNvSpPr>
+          <p:nvPr>
+            <p:ph type="sldNum" sz="quarter" idx="12"/>
+          </p:nvPr>
+        </p:nvSpPr>
+        <p:spPr/>
+        <p:txBody>
+          <a:bodyPr/>
+          <a:lstStyle/>
+          <a:p>
+            <a:pPr algn="r"/>
+            <a:r>
+              <a:rPr sz="1200" b="0" i="0">
+                <a:solidFill>
+                  <a:srgbClr val="787878"/>
+                </a:solidFill>
+                <a:latin typeface="Calibri"/>
+              </a:rPr>
+              <a:t>10</a:t>
+            </a:r>
+          </a:p>
+        </p:txBody>
+      </p:sp>
+    </p:spTree>
+    <p:extLst>
+      <p:ext uri="{BB962C8B-B14F-4D97-AF65-F5344CB8AC3E}">
+        <p14:creationId xmlns:p14="http://schemas.microsoft.com/office/powerpoint/2010/main" val="526818776"/>
+      </p:ext>
+    </p:extLst>
+  </p:cSld>
+  <p:clrMapOvr>
+    <a:masterClrMapping/>
+  </p:clrMapOvr>
+  <mc:AlternateContent xmlns:mc="http://schemas.openxmlformats.org/markup-compatibility/2006" xmlns:p14="http://schemas.microsoft.com/office/powerpoint/2010/main">
+    <mc:Choice Requires="p14">
+      <p:transition spd="med" p14:dur="700">
+        <p:fade/>
+      </p:transition>
+    </mc:Choice>
+    <mc:Fallback xmlns="">
+      <p:transition spd="med">
+        <p:fade/>
+      </p:transition>
+    </mc:Fallback>
+  </mc:AlternateContent>
+</p:sld>
+</file>
+
+<file path=ppt/slides/slide11.xml><?xml version="1.0" encoding="utf-8"?>
+<p:sld xmlns:a="http://schemas.openxmlformats.org/drawingml/2006/main" xmlns:r="http://schemas.openxmlformats.org/officeDocument/2006/relationships" xmlns:p="http://schemas.openxmlformats.org/presentationml/2006/main">
+  <p:cSld>
+    <p:spTree>
+      <p:nvGrpSpPr>
+        <p:cNvPr id="1" name=""/>
+        <p:cNvGrpSpPr/>
+        <p:nvPr/>
+      </p:nvGrpSpPr>
+      <p:grpSpPr>
+        <a:xfrm>
+          <a:off x="0" y="0"/>
+          <a:ext cx="0" cy="0"/>
+          <a:chOff x="0" y="0"/>
+          <a:chExt cx="0" cy="0"/>
+        </a:xfrm>
+      </p:grpSpPr>
+      <p:sp>
+        <p:nvSpPr>
           <p:cNvPr id="3" name="Content Placeholder 2"/>
           <p:cNvSpPr>
             <a:spLocks noGrp="1"/>
@@ -13638,228 +14234,6 @@
 </p:sld>
 </file>
 
-<file path=ppt/slides/slide11.xml><?xml version="1.0" encoding="utf-8"?>
-<p:sld xmlns:a="http://schemas.openxmlformats.org/drawingml/2006/main" xmlns:p="http://schemas.openxmlformats.org/presentationml/2006/main" xmlns:r="http://schemas.openxmlformats.org/officeDocument/2006/relationships">
-  <p:cSld>
-    <p:spTree>
-      <p:nvGrpSpPr>
-        <p:cNvPr id="1" name=""/>
-        <p:cNvGrpSpPr/>
-        <p:nvPr/>
-      </p:nvGrpSpPr>
-      <p:grpSpPr/>
-      <p:sp>
-        <p:nvSpPr>
-          <p:cNvPr id="2" name="Title 1"/>
-          <p:cNvSpPr>
-            <a:spLocks noGrp="1"/>
-          </p:cNvSpPr>
-          <p:nvPr>
-            <p:ph type="title"/>
-          </p:nvPr>
-        </p:nvSpPr>
-        <p:spPr/>
-        <p:txBody>
-          <a:bodyPr/>
-          <a:lstStyle/>
-          <a:p>
-            <a:r>
-              <a:rPr sz="3600" b="1" i="0">
-                <a:solidFill>
-                  <a:srgbClr val="102C57"/>
-                </a:solidFill>
-                <a:latin typeface="Calibri"/>
-              </a:rPr>
-              <a:t>Introduction</a:t>
-            </a:r>
-          </a:p>
-        </p:txBody>
-      </p:sp>
-      <p:sp>
-        <p:nvSpPr>
-          <p:cNvPr id="3" name="Content Placeholder 2"/>
-          <p:cNvSpPr>
-            <a:spLocks noGrp="1"/>
-          </p:cNvSpPr>
-          <p:nvPr>
-            <p:ph idx="1"/>
-          </p:nvPr>
-        </p:nvSpPr>
-        <p:spPr/>
-        <p:txBody>
-          <a:bodyPr/>
-          <a:lstStyle/>
-          <a:p/>
-          <a:p>
-            <a:pPr>
-              <a:spcAft>
-                <a:spcPts val="600"/>
-              </a:spcAft>
-            </a:pPr>
-            <a:r>
-              <a:rPr sz="1700" b="1" i="0">
-                <a:solidFill>
-                  <a:srgbClr val="102C57"/>
-                </a:solidFill>
-                <a:latin typeface="Calibri"/>
-              </a:rPr>
-              <a:t>• Online Recruitment Fraud (ORF) Threat: </a:t>
-            </a:r>
-            <a:r>
-              <a:rPr sz="1700" b="0" i="0">
-                <a:solidFill>
-                  <a:srgbClr val="323232"/>
-                </a:solidFill>
-                <a:latin typeface="Calibri"/>
-              </a:rPr>
-              <a:t>Cyber-criminals exploit professional job portals (LinkedIn, Indeed) by posting deceptive employment ads to extort application/visa fees and harvest confidential personal data (PII).</a:t>
-            </a:r>
-          </a:p>
-          <a:p>
-            <a:pPr>
-              <a:spcAft>
-                <a:spcPts val="600"/>
-              </a:spcAft>
-            </a:pPr>
-            <a:r>
-              <a:rPr sz="1700" b="1" i="0">
-                <a:solidFill>
-                  <a:srgbClr val="102C57"/>
-                </a:solidFill>
-                <a:latin typeface="Calibri"/>
-              </a:rPr>
-              <a:t>• Severe Real-World Class Imbalance: </a:t>
-            </a:r>
-            <a:r>
-              <a:rPr sz="1700" b="0" i="0">
-                <a:solidFill>
-                  <a:srgbClr val="323232"/>
-                </a:solidFill>
-                <a:latin typeface="Calibri"/>
-              </a:rPr>
-              <a:t>Genuine postings overwhelmingly dominate online platforms (&gt;95%), creating extreme class sparsity where fake postings account for less than 5% of all advertisements.</a:t>
-            </a:r>
-          </a:p>
-          <a:p>
-            <a:pPr>
-              <a:spcAft>
-                <a:spcPts val="600"/>
-              </a:spcAft>
-            </a:pPr>
-            <a:r>
-              <a:rPr sz="1700" b="1" i="0">
-                <a:solidFill>
-                  <a:srgbClr val="102C57"/>
-                </a:solidFill>
-                <a:latin typeface="Calibri"/>
-              </a:rPr>
-              <a:t>• Limitations of Traditional Machine Learning: </a:t>
-            </a:r>
-            <a:r>
-              <a:rPr sz="1700" b="0" i="0">
-                <a:solidFill>
-                  <a:srgbClr val="323232"/>
-                </a:solidFill>
-                <a:latin typeface="Calibri"/>
-              </a:rPr>
-              <a:t>Conventional algorithms (Logistic Regression, Support Vector Machines, Random Forests) rely on Bag-of-Words (BoW) and TF-IDF vectors, completely ignoring syntactic sentence structure and word order.</a:t>
-            </a:r>
-          </a:p>
-          <a:p>
-            <a:pPr>
-              <a:spcAft>
-                <a:spcPts val="600"/>
-              </a:spcAft>
-            </a:pPr>
-            <a:r>
-              <a:rPr sz="1700" b="1" i="0">
-                <a:solidFill>
-                  <a:srgbClr val="102C57"/>
-                </a:solidFill>
-                <a:latin typeface="Calibri"/>
-              </a:rPr>
-              <a:t>• Deficiencies of Static Word Embeddings: </a:t>
-            </a:r>
-            <a:r>
-              <a:rPr sz="1700" b="0" i="0">
-                <a:solidFill>
-                  <a:srgbClr val="323232"/>
-                </a:solidFill>
-                <a:latin typeface="Calibri"/>
-              </a:rPr>
-              <a:t>Early deep learning approaches (CNNs, standard LSTMs) utilize static embeddings (Word2Vec, GloVe) that assign a single fixed vector per word, failing to handle context-dependent polysemous fraud terms.</a:t>
-            </a:r>
-          </a:p>
-          <a:p>
-            <a:pPr>
-              <a:spcAft>
-                <a:spcPts val="600"/>
-              </a:spcAft>
-            </a:pPr>
-            <a:r>
-              <a:rPr sz="1700" b="1" i="0">
-                <a:solidFill>
-                  <a:srgbClr val="102C57"/>
-                </a:solidFill>
-                <a:latin typeface="Calibri"/>
-              </a:rPr>
-              <a:t>• Motivation for Transformer-Based Architecture: </a:t>
-            </a:r>
-            <a:r>
-              <a:rPr sz="1700" b="0" i="0">
-                <a:solidFill>
-                  <a:srgbClr val="323232"/>
-                </a:solidFill>
-                <a:latin typeface="Calibri"/>
-              </a:rPr>
-              <a:t>Pre-trained Bidirectional Encoder Representations from Transformers (BERT) leverage multi-head self-attention to dynamically capture bidirectional semantic dependencies, dramatically minimizing false positives.</a:t>
-            </a:r>
-          </a:p>
-        </p:txBody>
-      </p:sp>
-      <p:sp>
-        <p:nvSpPr>
-          <p:cNvPr id="4" name="TextBox 3"/>
-          <p:cNvSpPr txBox="1"/>
-          <p:nvPr/>
-        </p:nvSpPr>
-        <p:spPr>
-          <a:xfrm>
-            <a:off x="8613648" y="6355080"/>
-            <a:ext cx="2743200" cy="365760"/>
-          </a:xfrm>
-          <a:prstGeom prst="rect">
-            <a:avLst/>
-          </a:prstGeom>
-          <a:noFill/>
-        </p:spPr>
-        <p:txBody>
-          <a:bodyPr wrap="none">
-            <a:spAutoFit/>
-          </a:bodyPr>
-          <a:lstStyle/>
-          <a:p>
-            <a:pPr algn="r"/>
-            <a:r>
-              <a:rPr sz="1200" b="0" i="0">
-                <a:solidFill>
-                  <a:srgbClr val="787878"/>
-                </a:solidFill>
-                <a:latin typeface="Calibri"/>
-              </a:rPr>
-              <a:t>3</a:t>
-            </a:r>
-          </a:p>
-        </p:txBody>
-      </p:sp>
-    </p:spTree>
-  </p:cSld>
-  <p:clrMapOvr>
-    <a:masterClrMapping/>
-  </p:clrMapOvr>
-</p:sld>
-</file>
-
 <file path=ppt/slides/slide2.xml><?xml version="1.0" encoding="utf-8"?>
 <p:sld xmlns:a="http://schemas.openxmlformats.org/drawingml/2006/main" xmlns:r="http://schemas.openxmlformats.org/officeDocument/2006/relationships" xmlns:p="http://schemas.openxmlformats.org/presentationml/2006/main">
   <p:cSld>
@@ -13889,8 +14263,8 @@
         </p:nvSpPr>
         <p:spPr>
           <a:xfrm>
-            <a:off x="798681" y="347744"/>
-            <a:ext cx="2093686" cy="798287"/>
+            <a:off x="798680" y="347744"/>
+            <a:ext cx="3692039" cy="798287"/>
           </a:xfrm>
         </p:spPr>
         <p:txBody>
@@ -13900,7 +14274,7 @@
           <a:lstStyle/>
           <a:p>
             <a:r>
-              <a:rPr sz="3600" b="1" i="0">
+              <a:rPr sz="3600" b="1" i="0" dirty="0">
                 <a:solidFill>
                   <a:srgbClr val="102C57"/>
                 </a:solidFill>
@@ -13923,7 +14297,7 @@
         </p:nvSpPr>
         <p:spPr>
           <a:xfrm>
-            <a:off x="732693" y="1582057"/>
+            <a:off x="798680" y="1063171"/>
             <a:ext cx="10515600" cy="4731657"/>
           </a:xfrm>
         </p:spPr>
@@ -13932,7 +14306,9 @@
             <a:normAutofit/>
           </a:bodyPr>
           <a:lstStyle/>
-          <a:p/>
+          <a:p>
+            <a:endParaRPr dirty="0"/>
+          </a:p>
           <a:p>
             <a:pPr>
               <a:spcAft>
@@ -13940,23 +14316,20 @@
               </a:spcAft>
             </a:pPr>
             <a:r>
-              <a:rPr sz="1600" b="1" i="0">
+              <a:rPr sz="1600" b="1" i="0" dirty="0">
                 <a:solidFill>
                   <a:srgbClr val="102C57"/>
                 </a:solidFill>
                 <a:latin typeface="Calibri"/>
               </a:rPr>
-              <a:t>1. Introduction: </a:t>
-            </a:r>
-            <a:r>
-              <a:rPr sz="1600" b="0" i="0">
-                <a:solidFill>
-                  <a:srgbClr val="323232"/>
-                </a:solidFill>
-                <a:latin typeface="Calibri"/>
-              </a:rPr>
-              <a:t>Background on Online Recruitment Fraud (ORF) and challenges in automated scam detection.</a:t>
-            </a:r>
+              <a:t>1. Introduction</a:t>
+            </a:r>
+            <a:endParaRPr lang="en-US" sz="1600" b="1" dirty="0">
+              <a:solidFill>
+                <a:srgbClr val="102C57"/>
+              </a:solidFill>
+              <a:latin typeface="Calibri"/>
+            </a:endParaRPr>
           </a:p>
           <a:p>
             <a:pPr>
@@ -13965,23 +14338,20 @@
               </a:spcAft>
             </a:pPr>
             <a:r>
-              <a:rPr sz="1600" b="1" i="0">
+              <a:rPr sz="1600" b="1" i="0" dirty="0">
                 <a:solidFill>
                   <a:srgbClr val="102C57"/>
                 </a:solidFill>
                 <a:latin typeface="Calibri"/>
               </a:rPr>
-              <a:t>2. Literature Review: </a:t>
-            </a:r>
-            <a:r>
-              <a:rPr sz="1600" b="0" i="0">
-                <a:solidFill>
-                  <a:srgbClr val="323232"/>
-                </a:solidFill>
-                <a:latin typeface="Calibri"/>
-              </a:rPr>
-              <a:t>Comparative analysis of 5 landmark research studies in recruitment fraud detection.</a:t>
-            </a:r>
+              <a:t>2. Literature Review</a:t>
+            </a:r>
+            <a:endParaRPr lang="en-US" sz="1600" b="1" dirty="0">
+              <a:solidFill>
+                <a:srgbClr val="102C57"/>
+              </a:solidFill>
+              <a:latin typeface="Calibri"/>
+            </a:endParaRPr>
           </a:p>
           <a:p>
             <a:pPr>
@@ -13990,23 +14360,20 @@
               </a:spcAft>
             </a:pPr>
             <a:r>
-              <a:rPr sz="1600" b="1" i="0">
+              <a:rPr sz="1600" b="1" i="0" dirty="0">
                 <a:solidFill>
                   <a:srgbClr val="102C57"/>
                 </a:solidFill>
                 <a:latin typeface="Calibri"/>
               </a:rPr>
-              <a:t>3. Selected Landmark Study (Fraud-BERT): </a:t>
-            </a:r>
-            <a:r>
-              <a:rPr sz="1600" b="0" i="0">
-                <a:solidFill>
-                  <a:srgbClr val="323232"/>
-                </a:solidFill>
-                <a:latin typeface="Calibri"/>
-              </a:rPr>
-              <a:t>Research problem, scope, and core objectives by Taneja et al. (2025).</a:t>
-            </a:r>
+              <a:t>3. Selected Landmark Study (Fraud-BERT)</a:t>
+            </a:r>
+            <a:endParaRPr lang="en-US" sz="1600" b="1" i="0" dirty="0">
+              <a:solidFill>
+                <a:srgbClr val="102C57"/>
+              </a:solidFill>
+              <a:latin typeface="Calibri"/>
+            </a:endParaRPr>
           </a:p>
           <a:p>
             <a:pPr>
@@ -14015,23 +14382,20 @@
               </a:spcAft>
             </a:pPr>
             <a:r>
-              <a:rPr sz="1600" b="1" i="0">
+              <a:rPr sz="1600" b="1" i="0" dirty="0">
                 <a:solidFill>
                   <a:srgbClr val="102C57"/>
                 </a:solidFill>
                 <a:latin typeface="Calibri"/>
               </a:rPr>
-              <a:t>4. Machine Learning Methods &amp; Architecture: </a:t>
-            </a:r>
-            <a:r>
-              <a:rPr sz="1600" b="0" i="0">
-                <a:solidFill>
-                  <a:srgbClr val="323232"/>
-                </a:solidFill>
-                <a:latin typeface="Calibri"/>
-              </a:rPr>
-              <a:t>BERT transformer architecture, multi-head self-attention, and classification head.</a:t>
-            </a:r>
+              <a:t>4. Machine Learning Methods &amp; Architecture</a:t>
+            </a:r>
+            <a:endParaRPr lang="en-US" sz="1600" b="1" dirty="0">
+              <a:solidFill>
+                <a:srgbClr val="102C57"/>
+              </a:solidFill>
+              <a:latin typeface="Calibri"/>
+            </a:endParaRPr>
           </a:p>
           <a:p>
             <a:pPr>
@@ -14040,23 +14404,20 @@
               </a:spcAft>
             </a:pPr>
             <a:r>
-              <a:rPr sz="1600" b="1" i="0">
+              <a:rPr sz="1600" b="1" i="0" dirty="0">
                 <a:solidFill>
                   <a:srgbClr val="102C57"/>
                 </a:solidFill>
                 <a:latin typeface="Calibri"/>
               </a:rPr>
-              <a:t>5. Proposed Prediction Model Pipeline: </a:t>
-            </a:r>
-            <a:r>
-              <a:rPr sz="1600" b="0" i="0">
-                <a:solidFill>
-                  <a:srgbClr val="323232"/>
-                </a:solidFill>
-                <a:latin typeface="Calibri"/>
-              </a:rPr>
-              <a:t>5-stage end-to-end framework from text preprocessing &amp; tokenization to inference.</a:t>
-            </a:r>
+              <a:t>5. Proposed Prediction Model Pipeline</a:t>
+            </a:r>
+            <a:endParaRPr lang="en-US" sz="1600" b="1" dirty="0">
+              <a:solidFill>
+                <a:srgbClr val="102C57"/>
+              </a:solidFill>
+              <a:latin typeface="Calibri"/>
+            </a:endParaRPr>
           </a:p>
           <a:p>
             <a:pPr>
@@ -14065,23 +14426,20 @@
               </a:spcAft>
             </a:pPr>
             <a:r>
-              <a:rPr sz="1600" b="1" i="0">
+              <a:rPr sz="1600" b="1" i="0" dirty="0">
                 <a:solidFill>
                   <a:srgbClr val="102C57"/>
                 </a:solidFill>
                 <a:latin typeface="Calibri"/>
               </a:rPr>
-              <a:t>6. Dataset &amp; Class Imbalance Analysis: </a:t>
-            </a:r>
-            <a:r>
-              <a:rPr sz="1600" b="0" i="0">
-                <a:solidFill>
-                  <a:srgbClr val="323232"/>
-                </a:solidFill>
-                <a:latin typeface="Calibri"/>
-              </a:rPr>
-              <a:t>EMSCAD benchmark dataset characteristics, attribute types, and severe 95:5 class imbalance.</a:t>
-            </a:r>
+              <a:t>6. Dataset &amp; Class Imbalance Analysis</a:t>
+            </a:r>
+            <a:endParaRPr lang="en-US" sz="1600" b="1" dirty="0">
+              <a:solidFill>
+                <a:srgbClr val="102C57"/>
+              </a:solidFill>
+              <a:latin typeface="Calibri"/>
+            </a:endParaRPr>
           </a:p>
           <a:p>
             <a:pPr>
@@ -14090,23 +14448,20 @@
               </a:spcAft>
             </a:pPr>
             <a:r>
-              <a:rPr sz="1600" b="1" i="0">
+              <a:rPr sz="1600" b="1" i="0" dirty="0">
                 <a:solidFill>
                   <a:srgbClr val="102C57"/>
                 </a:solidFill>
                 <a:latin typeface="Calibri"/>
               </a:rPr>
-              <a:t>7. Results &amp; Comparative Performance: </a:t>
-            </a:r>
-            <a:r>
-              <a:rPr sz="1600" b="0" i="0">
-                <a:solidFill>
-                  <a:srgbClr val="323232"/>
-                </a:solidFill>
-                <a:latin typeface="Calibri"/>
-              </a:rPr>
-              <a:t>Empirical performance evaluation (Accuracy, Macro F1, Recall, ROC-AUC) against baselines.</a:t>
-            </a:r>
+              <a:t>7. Results &amp; Comparative Performance</a:t>
+            </a:r>
+            <a:endParaRPr lang="en-US" sz="1600" b="1" dirty="0">
+              <a:solidFill>
+                <a:srgbClr val="102C57"/>
+              </a:solidFill>
+              <a:latin typeface="Calibri"/>
+            </a:endParaRPr>
           </a:p>
           <a:p>
             <a:pPr>
@@ -14115,23 +14470,20 @@
               </a:spcAft>
             </a:pPr>
             <a:r>
-              <a:rPr sz="1600" b="1" i="0">
+              <a:rPr sz="1600" b="1" i="0" dirty="0">
                 <a:solidFill>
                   <a:srgbClr val="102C57"/>
                 </a:solidFill>
                 <a:latin typeface="Calibri"/>
               </a:rPr>
-              <a:t>8. Bibliography or References: </a:t>
-            </a:r>
-            <a:r>
-              <a:rPr sz="1600" b="0" i="0">
-                <a:solidFill>
-                  <a:srgbClr val="323232"/>
-                </a:solidFill>
-                <a:latin typeface="Calibri"/>
-              </a:rPr>
-              <a:t>Complete bibliographic citations of the 5 reviewed studies in standard APA 7th edition format.</a:t>
-            </a:r>
+              <a:t>8. Bibliography or References</a:t>
+            </a:r>
+            <a:endParaRPr sz="1600" b="0" i="0" dirty="0">
+              <a:solidFill>
+                <a:srgbClr val="323232"/>
+              </a:solidFill>
+              <a:latin typeface="Calibri"/>
+            </a:endParaRPr>
           </a:p>
         </p:txBody>
       </p:sp>
@@ -14217,6 +14569,287 @@
         </p:nvSpPr>
         <p:spPr>
           <a:xfrm>
+            <a:off x="838200" y="137160"/>
+            <a:ext cx="10515600" cy="1325563"/>
+          </a:xfrm>
+        </p:spPr>
+        <p:txBody>
+          <a:bodyPr/>
+          <a:lstStyle/>
+          <a:p>
+            <a:r>
+              <a:rPr sz="3600" b="1" i="0" dirty="0">
+                <a:solidFill>
+                  <a:srgbClr val="102C57"/>
+                </a:solidFill>
+                <a:latin typeface="Calibri"/>
+              </a:rPr>
+              <a:t>Introduction</a:t>
+            </a:r>
+          </a:p>
+        </p:txBody>
+      </p:sp>
+      <p:sp>
+        <p:nvSpPr>
+          <p:cNvPr id="3" name="Content Placeholder 2"/>
+          <p:cNvSpPr>
+            <a:spLocks noGrp="1"/>
+          </p:cNvSpPr>
+          <p:nvPr>
+            <p:ph idx="1"/>
+          </p:nvPr>
+        </p:nvSpPr>
+        <p:spPr>
+          <a:xfrm>
+            <a:off x="838200" y="1378585"/>
+            <a:ext cx="10515600" cy="4351338"/>
+          </a:xfrm>
+        </p:spPr>
+        <p:txBody>
+          <a:bodyPr>
+            <a:normAutofit/>
+          </a:bodyPr>
+          <a:lstStyle/>
+          <a:p>
+            <a:pPr marL="0" indent="0" algn="just">
+              <a:spcAft>
+                <a:spcPts val="600"/>
+              </a:spcAft>
+              <a:buNone/>
+            </a:pPr>
+            <a:r>
+              <a:rPr sz="1700" b="1" i="0" dirty="0">
+                <a:solidFill>
+                  <a:srgbClr val="102C57"/>
+                </a:solidFill>
+                <a:latin typeface="Calibri"/>
+              </a:rPr>
+              <a:t>• Online Recruitment Fraud (ORF) Threat: </a:t>
+            </a:r>
+            <a:r>
+              <a:rPr sz="1700" b="0" i="0" dirty="0">
+                <a:solidFill>
+                  <a:srgbClr val="323232"/>
+                </a:solidFill>
+                <a:latin typeface="Calibri"/>
+              </a:rPr>
+              <a:t>Cyber-criminals exploit professional job portals (LinkedIn, Indeed) by posting deceptive employment ads to extort application/visa fees and harvest confidential personal data (PII).</a:t>
+            </a:r>
+          </a:p>
+          <a:p>
+            <a:pPr marL="0" indent="0" algn="just">
+              <a:spcAft>
+                <a:spcPts val="600"/>
+              </a:spcAft>
+              <a:buNone/>
+            </a:pPr>
+            <a:r>
+              <a:rPr sz="1700" b="1" i="0" dirty="0">
+                <a:solidFill>
+                  <a:srgbClr val="102C57"/>
+                </a:solidFill>
+                <a:latin typeface="Calibri"/>
+              </a:rPr>
+              <a:t>• Severe Real-World Class Imbalance: </a:t>
+            </a:r>
+            <a:r>
+              <a:rPr sz="1700" b="0" i="0" dirty="0">
+                <a:solidFill>
+                  <a:srgbClr val="323232"/>
+                </a:solidFill>
+                <a:latin typeface="Calibri"/>
+              </a:rPr>
+              <a:t>Genuine postings overwhelmingly dominate online platforms (&gt;95%), creating extreme class sparsity where fake postings account for less than 5% of all advertisements.</a:t>
+            </a:r>
+          </a:p>
+          <a:p>
+            <a:pPr marL="0" indent="0" algn="just">
+              <a:spcAft>
+                <a:spcPts val="600"/>
+              </a:spcAft>
+              <a:buNone/>
+            </a:pPr>
+            <a:r>
+              <a:rPr sz="1700" b="1" i="0" dirty="0">
+                <a:solidFill>
+                  <a:srgbClr val="102C57"/>
+                </a:solidFill>
+                <a:latin typeface="Calibri"/>
+              </a:rPr>
+              <a:t>• Limitations of Traditional Machine Learning: </a:t>
+            </a:r>
+            <a:r>
+              <a:rPr sz="1700" b="0" i="0" dirty="0">
+                <a:solidFill>
+                  <a:srgbClr val="323232"/>
+                </a:solidFill>
+                <a:latin typeface="Calibri"/>
+              </a:rPr>
+              <a:t>Conventional algorithms (Logistic Regression, Support Vector Machines, Random Forests) rely on Bag-of-Words (</a:t>
+            </a:r>
+            <a:r>
+              <a:rPr sz="1700" b="0" i="0" dirty="0" err="1">
+                <a:solidFill>
+                  <a:srgbClr val="323232"/>
+                </a:solidFill>
+                <a:latin typeface="Calibri"/>
+              </a:rPr>
+              <a:t>BoW</a:t>
+            </a:r>
+            <a:r>
+              <a:rPr sz="1700" b="0" i="0" dirty="0">
+                <a:solidFill>
+                  <a:srgbClr val="323232"/>
+                </a:solidFill>
+                <a:latin typeface="Calibri"/>
+              </a:rPr>
+              <a:t>) and TF-IDF vectors, completely ignoring syntactic sentence structure and word order.</a:t>
+            </a:r>
+          </a:p>
+          <a:p>
+            <a:pPr marL="0" indent="0" algn="just">
+              <a:spcAft>
+                <a:spcPts val="600"/>
+              </a:spcAft>
+              <a:buNone/>
+            </a:pPr>
+            <a:r>
+              <a:rPr sz="1700" b="1" i="0" dirty="0">
+                <a:solidFill>
+                  <a:srgbClr val="102C57"/>
+                </a:solidFill>
+                <a:latin typeface="Calibri"/>
+              </a:rPr>
+              <a:t>• Deficiencies of Static Word Embeddings: </a:t>
+            </a:r>
+            <a:r>
+              <a:rPr sz="1700" b="0" i="0" dirty="0">
+                <a:solidFill>
+                  <a:srgbClr val="323232"/>
+                </a:solidFill>
+                <a:latin typeface="Calibri"/>
+              </a:rPr>
+              <a:t>Early deep learning approaches (CNNs, standard LSTMs) utilize static embeddings (Word2Vec, </a:t>
+            </a:r>
+            <a:r>
+              <a:rPr sz="1700" b="0" i="0" dirty="0" err="1">
+                <a:solidFill>
+                  <a:srgbClr val="323232"/>
+                </a:solidFill>
+                <a:latin typeface="Calibri"/>
+              </a:rPr>
+              <a:t>GloVe</a:t>
+            </a:r>
+            <a:r>
+              <a:rPr sz="1700" b="0" i="0" dirty="0">
+                <a:solidFill>
+                  <a:srgbClr val="323232"/>
+                </a:solidFill>
+                <a:latin typeface="Calibri"/>
+              </a:rPr>
+              <a:t>) that assign a single fixed vector per word, failing to handle context-dependent polysemous fraud terms.</a:t>
+            </a:r>
+          </a:p>
+          <a:p>
+            <a:pPr marL="0" indent="0" algn="just">
+              <a:spcAft>
+                <a:spcPts val="600"/>
+              </a:spcAft>
+              <a:buNone/>
+            </a:pPr>
+            <a:r>
+              <a:rPr sz="1700" b="1" i="0" dirty="0">
+                <a:solidFill>
+                  <a:srgbClr val="102C57"/>
+                </a:solidFill>
+                <a:latin typeface="Calibri"/>
+              </a:rPr>
+              <a:t>• Motivation for Transformer-Based Architecture: </a:t>
+            </a:r>
+            <a:r>
+              <a:rPr sz="1700" b="0" i="0" dirty="0">
+                <a:solidFill>
+                  <a:srgbClr val="323232"/>
+                </a:solidFill>
+                <a:latin typeface="Calibri"/>
+              </a:rPr>
+              <a:t>Pre-trained Bidirectional Encoder Representations from Transformers (BERT) leverage multi-head self-attention to dynamically capture bidirectional semantic dependencies, dramatically minimizing false positives.</a:t>
+            </a:r>
+          </a:p>
+        </p:txBody>
+      </p:sp>
+      <p:sp>
+        <p:nvSpPr>
+          <p:cNvPr id="4" name="TextBox 3"/>
+          <p:cNvSpPr txBox="1"/>
+          <p:nvPr/>
+        </p:nvSpPr>
+        <p:spPr>
+          <a:xfrm>
+            <a:off x="8613648" y="6355080"/>
+            <a:ext cx="2743200" cy="365760"/>
+          </a:xfrm>
+          <a:prstGeom prst="rect">
+            <a:avLst/>
+          </a:prstGeom>
+          <a:noFill/>
+        </p:spPr>
+        <p:txBody>
+          <a:bodyPr wrap="none">
+            <a:spAutoFit/>
+          </a:bodyPr>
+          <a:lstStyle/>
+          <a:p>
+            <a:pPr algn="r"/>
+            <a:r>
+              <a:rPr sz="1200" b="0" i="0">
+                <a:solidFill>
+                  <a:srgbClr val="787878"/>
+                </a:solidFill>
+                <a:latin typeface="Calibri"/>
+              </a:rPr>
+              <a:t>3</a:t>
+            </a:r>
+          </a:p>
+        </p:txBody>
+      </p:sp>
+    </p:spTree>
+  </p:cSld>
+  <p:clrMapOvr>
+    <a:masterClrMapping/>
+  </p:clrMapOvr>
+</p:sld>
+</file>
+
+<file path=ppt/slides/slide4.xml><?xml version="1.0" encoding="utf-8"?>
+<p:sld xmlns:a="http://schemas.openxmlformats.org/drawingml/2006/main" xmlns:r="http://schemas.openxmlformats.org/officeDocument/2006/relationships" xmlns:p="http://schemas.openxmlformats.org/presentationml/2006/main">
+  <p:cSld>
+    <p:spTree>
+      <p:nvGrpSpPr>
+        <p:cNvPr id="1" name=""/>
+        <p:cNvGrpSpPr/>
+        <p:nvPr/>
+      </p:nvGrpSpPr>
+      <p:grpSpPr>
+        <a:xfrm>
+          <a:off x="0" y="0"/>
+          <a:ext cx="0" cy="0"/>
+          <a:chOff x="0" y="0"/>
+          <a:chExt cx="0" cy="0"/>
+        </a:xfrm>
+      </p:grpSpPr>
+      <p:sp>
+        <p:nvSpPr>
+          <p:cNvPr id="2" name="Title 1"/>
+          <p:cNvSpPr>
+            <a:spLocks noGrp="1"/>
+          </p:cNvSpPr>
+          <p:nvPr>
+            <p:ph type="title"/>
+          </p:nvPr>
+        </p:nvSpPr>
+        <p:spPr>
+          <a:xfrm>
             <a:off x="762785" y="331417"/>
             <a:ext cx="10515600" cy="716437"/>
           </a:xfrm>
@@ -14282,14 +14915,14 @@
           <p:nvPr>
             <p:extLst>
               <p:ext uri="{D42A27DB-BD31-4B8C-83A1-F6EECF244321}">
-                <p14:modId xmlns:p14="http://schemas.microsoft.com/office/powerpoint/2010/main" val="4005888794"/>
+                <p14:modId xmlns:p14="http://schemas.microsoft.com/office/powerpoint/2010/main" val="245205221"/>
               </p:ext>
             </p:extLst>
           </p:nvPr>
         </p:nvGraphicFramePr>
         <p:xfrm>
           <a:off x="838200" y="1306567"/>
-          <a:ext cx="10153455" cy="4937760"/>
+          <a:ext cx="10153455" cy="4450080"/>
         </p:xfrm>
         <a:graphic>
           <a:graphicData uri="http://schemas.openxmlformats.org/drawingml/2006/table">
@@ -14335,7 +14968,7 @@
                     <a:p>
                       <a:pPr algn="ctr"/>
                       <a:r>
-                        <a:rPr sz="1500" b="1" i="0">
+                        <a:rPr sz="2000" b="1" i="0" dirty="0">
                           <a:solidFill>
                             <a:srgbClr val="102C57"/>
                           </a:solidFill>
@@ -14354,7 +14987,7 @@
                     <a:p>
                       <a:pPr algn="ctr"/>
                       <a:r>
-                        <a:rPr sz="1500" b="1" i="0">
+                        <a:rPr sz="2000" b="1" i="0">
                           <a:solidFill>
                             <a:srgbClr val="102C57"/>
                           </a:solidFill>
@@ -14373,7 +15006,7 @@
                     <a:p>
                       <a:pPr algn="ctr"/>
                       <a:r>
-                        <a:rPr sz="1500" b="1" i="0">
+                        <a:rPr sz="2000" b="1" i="0">
                           <a:solidFill>
                             <a:srgbClr val="102C57"/>
                           </a:solidFill>
@@ -14392,7 +15025,7 @@
                     <a:p>
                       <a:pPr algn="ctr"/>
                       <a:r>
-                        <a:rPr sz="1500" b="1" i="0">
+                        <a:rPr sz="2000" b="1" i="0">
                           <a:solidFill>
                             <a:srgbClr val="102C57"/>
                           </a:solidFill>
@@ -14418,7 +15051,7 @@
                     <a:p>
                       <a:pPr algn="ctr"/>
                       <a:r>
-                        <a:rPr sz="1300" b="0" i="0">
+                        <a:rPr sz="1800" b="0" i="0">
                           <a:solidFill>
                             <a:srgbClr val="323232"/>
                           </a:solidFill>
@@ -14437,7 +15070,7 @@
                     <a:p>
                       <a:pPr algn="l"/>
                       <a:r>
-                        <a:rPr sz="1300" b="1" i="0">
+                        <a:rPr sz="1800" b="1" i="0">
                           <a:solidFill>
                             <a:srgbClr val="323232"/>
                           </a:solidFill>
@@ -14456,7 +15089,7 @@
                     <a:p>
                       <a:pPr algn="l"/>
                       <a:r>
-                        <a:rPr sz="1300" b="0" i="0">
+                        <a:rPr sz="1800" b="0" i="0">
                           <a:solidFill>
                             <a:srgbClr val="323232"/>
                           </a:solidFill>
@@ -14473,9 +15106,9 @@
                     <a:bodyPr/>
                     <a:lstStyle/>
                     <a:p>
-                      <a:pPr algn="ctr"/>
+                      <a:pPr algn="l"/>
                       <a:r>
-                        <a:rPr sz="1300" b="0" i="0">
+                        <a:rPr sz="1800" b="0" i="0">
                           <a:solidFill>
                             <a:srgbClr val="323232"/>
                           </a:solidFill>
@@ -14501,7 +15134,7 @@
                     <a:p>
                       <a:pPr algn="ctr"/>
                       <a:r>
-                        <a:rPr sz="1300" b="0" i="0">
+                        <a:rPr sz="1800" b="0" i="0">
                           <a:solidFill>
                             <a:srgbClr val="323232"/>
                           </a:solidFill>
@@ -14520,7 +15153,7 @@
                     <a:p>
                       <a:pPr algn="l"/>
                       <a:r>
-                        <a:rPr sz="1300" b="0" i="0">
+                        <a:rPr sz="1800" b="0" i="0">
                           <a:solidFill>
                             <a:srgbClr val="323232"/>
                           </a:solidFill>
@@ -14539,7 +15172,7 @@
                     <a:p>
                       <a:pPr algn="l"/>
                       <a:r>
-                        <a:rPr sz="1300" b="0" i="0">
+                        <a:rPr sz="1800" b="0" i="0">
                           <a:solidFill>
                             <a:srgbClr val="323232"/>
                           </a:solidFill>
@@ -14556,9 +15189,9 @@
                     <a:bodyPr/>
                     <a:lstStyle/>
                     <a:p>
-                      <a:pPr algn="ctr"/>
+                      <a:pPr algn="l"/>
                       <a:r>
-                        <a:rPr sz="1300" b="0" i="0">
+                        <a:rPr sz="1800" b="0" i="0">
                           <a:solidFill>
                             <a:srgbClr val="323232"/>
                           </a:solidFill>
@@ -14584,7 +15217,7 @@
                     <a:p>
                       <a:pPr algn="ctr"/>
                       <a:r>
-                        <a:rPr sz="1300" b="0" i="0">
+                        <a:rPr sz="1800" b="0" i="0">
                           <a:solidFill>
                             <a:srgbClr val="323232"/>
                           </a:solidFill>
@@ -14603,7 +15236,7 @@
                     <a:p>
                       <a:pPr algn="l"/>
                       <a:r>
-                        <a:rPr sz="1300" b="0" i="0">
+                        <a:rPr sz="1800" b="0" i="0">
                           <a:solidFill>
                             <a:srgbClr val="323232"/>
                           </a:solidFill>
@@ -14622,7 +15255,7 @@
                     <a:p>
                       <a:pPr algn="l"/>
                       <a:r>
-                        <a:rPr sz="1300" b="0" i="0">
+                        <a:rPr sz="1800" b="0" i="0">
                           <a:solidFill>
                             <a:srgbClr val="323232"/>
                           </a:solidFill>
@@ -14639,9 +15272,9 @@
                     <a:bodyPr/>
                     <a:lstStyle/>
                     <a:p>
-                      <a:pPr algn="ctr"/>
+                      <a:pPr algn="l"/>
                       <a:r>
-                        <a:rPr sz="1300" b="0" i="0">
+                        <a:rPr sz="1800" b="0" i="0">
                           <a:solidFill>
                             <a:srgbClr val="323232"/>
                           </a:solidFill>
@@ -14667,7 +15300,7 @@
                     <a:p>
                       <a:pPr algn="ctr"/>
                       <a:r>
-                        <a:rPr sz="1300" b="0" i="0">
+                        <a:rPr sz="1800" b="0" i="0">
                           <a:solidFill>
                             <a:srgbClr val="323232"/>
                           </a:solidFill>
@@ -14686,7 +15319,7 @@
                     <a:p>
                       <a:pPr algn="l"/>
                       <a:r>
-                        <a:rPr sz="1300" b="0" i="0">
+                        <a:rPr sz="1800" b="0" i="0">
                           <a:solidFill>
                             <a:srgbClr val="323232"/>
                           </a:solidFill>
@@ -14705,7 +15338,7 @@
                     <a:p>
                       <a:pPr algn="l"/>
                       <a:r>
-                        <a:rPr sz="1300" b="0" i="0">
+                        <a:rPr sz="1800" b="0" i="0">
                           <a:solidFill>
                             <a:srgbClr val="323232"/>
                           </a:solidFill>
@@ -14722,9 +15355,9 @@
                     <a:bodyPr/>
                     <a:lstStyle/>
                     <a:p>
-                      <a:pPr algn="ctr"/>
+                      <a:pPr algn="l"/>
                       <a:r>
-                        <a:rPr sz="1300" b="0" i="0">
+                        <a:rPr sz="1800" b="0" i="0">
                           <a:solidFill>
                             <a:srgbClr val="323232"/>
                           </a:solidFill>
@@ -14750,7 +15383,7 @@
                     <a:p>
                       <a:pPr algn="ctr"/>
                       <a:r>
-                        <a:rPr sz="1300" b="0" i="0">
+                        <a:rPr sz="1800" b="0" i="0">
                           <a:solidFill>
                             <a:srgbClr val="323232"/>
                           </a:solidFill>
@@ -14769,7 +15402,7 @@
                     <a:p>
                       <a:pPr algn="l"/>
                       <a:r>
-                        <a:rPr sz="1300" b="0" i="0">
+                        <a:rPr sz="1800" b="0" i="0">
                           <a:solidFill>
                             <a:srgbClr val="323232"/>
                           </a:solidFill>
@@ -14788,7 +15421,7 @@
                     <a:p>
                       <a:pPr algn="l"/>
                       <a:r>
-                        <a:rPr sz="1300" b="0" i="0">
+                        <a:rPr sz="1800" b="0" i="0">
                           <a:solidFill>
                             <a:srgbClr val="323232"/>
                           </a:solidFill>
@@ -14805,9 +15438,9 @@
                     <a:bodyPr/>
                     <a:lstStyle/>
                     <a:p>
-                      <a:pPr algn="ctr"/>
+                      <a:pPr algn="l"/>
                       <a:r>
-                        <a:rPr sz="1300" b="0" i="0">
+                        <a:rPr sz="1800" b="0" i="0" dirty="0">
                           <a:solidFill>
                             <a:srgbClr val="323232"/>
                           </a:solidFill>
@@ -14854,283 +15487,6 @@
 </p:sld>
 </file>
 
-<file path=ppt/slides/slide4.xml><?xml version="1.0" encoding="utf-8"?>
-<p:sld xmlns:a="http://schemas.openxmlformats.org/drawingml/2006/main" xmlns:r="http://schemas.openxmlformats.org/officeDocument/2006/relationships" xmlns:p="http://schemas.openxmlformats.org/presentationml/2006/main">
-  <p:cSld>
-    <p:spTree>
-      <p:nvGrpSpPr>
-        <p:cNvPr id="1" name=""/>
-        <p:cNvGrpSpPr/>
-        <p:nvPr/>
-      </p:nvGrpSpPr>
-      <p:grpSpPr>
-        <a:xfrm>
-          <a:off x="0" y="0"/>
-          <a:ext cx="0" cy="0"/>
-          <a:chOff x="0" y="0"/>
-          <a:chExt cx="0" cy="0"/>
-        </a:xfrm>
-      </p:grpSpPr>
-      <p:sp>
-        <p:nvSpPr>
-          <p:cNvPr id="2" name="Title 1"/>
-          <p:cNvSpPr>
-            <a:spLocks noGrp="1"/>
-          </p:cNvSpPr>
-          <p:nvPr>
-            <p:ph type="title"/>
-          </p:nvPr>
-        </p:nvSpPr>
-        <p:spPr>
-          <a:xfrm>
-            <a:off x="838200" y="294854"/>
-            <a:ext cx="10515600" cy="1325563"/>
-          </a:xfrm>
-        </p:spPr>
-        <p:txBody>
-          <a:bodyPr>
-            <a:normAutofit fontScale="90000"/>
-          </a:bodyPr>
-          <a:lstStyle/>
-          <a:p>
-            <a:r>
-              <a:rPr sz="2600" b="1" i="0">
-                <a:solidFill>
-                  <a:srgbClr val="102C57"/>
-                </a:solidFill>
-                <a:latin typeface="Calibri"/>
-              </a:rPr>
-              <a:t>Fraud-BERT: Transformer Based Context Aware Online Recruitment Fraud Detection</a:t>
-            </a:r>
-          </a:p>
-          <a:p>
-            <a:r>
-              <a:rPr sz="1600" b="0" i="1">
-                <a:solidFill>
-                  <a:srgbClr val="0066CC"/>
-                </a:solidFill>
-                <a:latin typeface="Calibri"/>
-              </a:rPr>
-              <a:t>DOI: 10.1007/s44425-025-00109-x  |  Discover Computing (Springer, 2025)</a:t>
-            </a:r>
-          </a:p>
-        </p:txBody>
-      </p:sp>
-      <p:sp>
-        <p:nvSpPr>
-          <p:cNvPr id="3" name="Content Placeholder 2"/>
-          <p:cNvSpPr>
-            <a:spLocks noGrp="1"/>
-          </p:cNvSpPr>
-          <p:nvPr>
-            <p:ph idx="1"/>
-          </p:nvPr>
-        </p:nvSpPr>
-        <p:spPr>
-          <a:xfrm>
-            <a:off x="838200" y="2415805"/>
-            <a:ext cx="10515600" cy="3707860"/>
-          </a:xfrm>
-        </p:spPr>
-        <p:txBody>
-          <a:bodyPr>
-            <a:noAutofit/>
-          </a:bodyPr>
-          <a:lstStyle/>
-          <a:p/>
-          <a:p>
-            <a:pPr>
-              <a:spcAft>
-                <a:spcPts val="1000"/>
-              </a:spcAft>
-            </a:pPr>
-            <a:r>
-              <a:rPr sz="2000" b="1" i="0">
-                <a:solidFill>
-                  <a:srgbClr val="102C57"/>
-                </a:solidFill>
-                <a:latin typeface="Calibri"/>
-              </a:rPr>
-              <a:t>Goal: </a:t>
-            </a:r>
-            <a:r>
-              <a:rPr sz="2000" b="0" i="0">
-                <a:solidFill>
-                  <a:srgbClr val="323232"/>
-                </a:solidFill>
-                <a:latin typeface="Calibri"/>
-              </a:rPr>
-              <a:t>To develop a high-accuracy, context-aware online recruitment fraud detection framework using fine-tuned BERT transformer architecture.</a:t>
-            </a:r>
-          </a:p>
-          <a:p>
-            <a:pPr>
-              <a:spcAft>
-                <a:spcPts val="600"/>
-              </a:spcAft>
-            </a:pPr>
-            <a:r>
-              <a:rPr sz="2000" b="1" i="0">
-                <a:solidFill>
-                  <a:srgbClr val="102C57"/>
-                </a:solidFill>
-                <a:latin typeface="Calibri"/>
-              </a:rPr>
-              <a:t>Why this study is important:</a:t>
-            </a:r>
-          </a:p>
-          <a:p>
-            <a:pPr>
-              <a:spcAft>
-                <a:spcPts val="600"/>
-              </a:spcAft>
-            </a:pPr>
-            <a:r>
-              <a:rPr sz="1800" b="0" i="0">
-                <a:solidFill>
-                  <a:srgbClr val="323232"/>
-                </a:solidFill>
-                <a:latin typeface="Calibri"/>
-              </a:rPr>
-              <a:t>• Online job scams deceive vulnerable job seekers, causing severe monetary extortion, identity theft, and data compromise.</a:t>
-            </a:r>
-          </a:p>
-          <a:p>
-            <a:pPr>
-              <a:spcAft>
-                <a:spcPts val="600"/>
-              </a:spcAft>
-            </a:pPr>
-            <a:r>
-              <a:rPr sz="1800" b="0" i="0">
-                <a:solidFill>
-                  <a:srgbClr val="323232"/>
-                </a:solidFill>
-                <a:latin typeface="Calibri"/>
-              </a:rPr>
-              <a:t>• Traditional machine learning models (LR, SVM, RF) rely on bag-of-words or static embeddings that ignore linguistic context, word order, and polysemy.</a:t>
-            </a:r>
-          </a:p>
-          <a:p>
-            <a:pPr>
-              <a:spcAft>
-                <a:spcPts val="600"/>
-              </a:spcAft>
-            </a:pPr>
-            <a:r>
-              <a:rPr sz="1800" b="0" i="0">
-                <a:solidFill>
-                  <a:srgbClr val="323232"/>
-                </a:solidFill>
-                <a:latin typeface="Calibri"/>
-              </a:rPr>
-              <a:t>• Transformer-based bidirectional self-attention enables deep contextual awareness, significantly reducing false alarms and improving detection reliability on highly imbalanced job post data.</a:t>
-            </a:r>
-          </a:p>
-        </p:txBody>
-      </p:sp>
-      <p:sp>
-        <p:nvSpPr>
-          <p:cNvPr id="4" name="Slide Number Placeholder 3"/>
-          <p:cNvSpPr>
-            <a:spLocks noGrp="1"/>
-          </p:cNvSpPr>
-          <p:nvPr>
-            <p:ph type="sldNum" sz="quarter" idx="12"/>
-          </p:nvPr>
-        </p:nvSpPr>
-        <p:spPr/>
-        <p:txBody>
-          <a:bodyPr/>
-          <a:lstStyle/>
-          <a:p>
-            <a:pPr algn="r"/>
-            <a:r>
-              <a:rPr sz="1200" b="0" i="0">
-                <a:solidFill>
-                  <a:srgbClr val="787878"/>
-                </a:solidFill>
-                <a:latin typeface="Calibri"/>
-              </a:rPr>
-              <a:t>5</a:t>
-            </a:r>
-          </a:p>
-        </p:txBody>
-      </p:sp>
-      <p:sp>
-        <p:nvSpPr>
-          <p:cNvPr id="5" name="TextBox 4">
-            <a:extLst>
-              <a:ext uri="{FF2B5EF4-FFF2-40B4-BE49-F238E27FC236}">
-                <a16:creationId xmlns:a16="http://schemas.microsoft.com/office/drawing/2014/main" id="{321DD254-6A9D-EC5A-3C0F-9005CE174E46}"/>
-              </a:ext>
-            </a:extLst>
-          </p:cNvPr>
-          <p:cNvSpPr txBox="1"/>
-          <p:nvPr/>
-        </p:nvSpPr>
-        <p:spPr>
-          <a:xfrm>
-            <a:off x="838200" y="1620417"/>
-            <a:ext cx="3836307" cy="461665"/>
-          </a:xfrm>
-          <a:prstGeom prst="rect">
-            <a:avLst/>
-          </a:prstGeom>
-          <a:noFill/>
-        </p:spPr>
-        <p:txBody>
-          <a:bodyPr wrap="none" rtlCol="0">
-            <a:spAutoFit/>
-          </a:bodyPr>
-          <a:lstStyle/>
-          <a:p>
-            <a:r>
-              <a:rPr sz="2000" b="1" i="0">
-                <a:solidFill>
-                  <a:srgbClr val="102C57"/>
-                </a:solidFill>
-                <a:latin typeface="Calibri"/>
-              </a:rPr>
-              <a:t>Authors: </a:t>
-            </a:r>
-            <a:r>
-              <a:rPr sz="2000" b="0" i="0">
-                <a:solidFill>
-                  <a:srgbClr val="323232"/>
-                </a:solidFill>
-                <a:latin typeface="Calibri"/>
-              </a:rPr>
-              <a:t>Khushboo Taneja, Jyoti Vashishtha, Saroj Ratnoo</a:t>
-            </a:r>
-          </a:p>
-        </p:txBody>
-      </p:sp>
-    </p:spTree>
-    <p:extLst>
-      <p:ext uri="{BB962C8B-B14F-4D97-AF65-F5344CB8AC3E}">
-        <p14:creationId xmlns:p14="http://schemas.microsoft.com/office/powerpoint/2010/main" val="4093034545"/>
-      </p:ext>
-    </p:extLst>
-  </p:cSld>
-  <p:clrMapOvr>
-    <a:masterClrMapping/>
-  </p:clrMapOvr>
-  <mc:AlternateContent xmlns:mc="http://schemas.openxmlformats.org/markup-compatibility/2006" xmlns:p14="http://schemas.microsoft.com/office/powerpoint/2010/main">
-    <mc:Choice Requires="p14">
-      <p:transition spd="med" p14:dur="700">
-        <p:fade/>
-      </p:transition>
-    </mc:Choice>
-    <mc:Fallback xmlns="">
-      <p:transition spd="med">
-        <p:fade/>
-      </p:transition>
-    </mc:Fallback>
-  </mc:AlternateContent>
-</p:sld>
-</file>
-
 <file path=ppt/slides/slide5.xml><?xml version="1.0" encoding="utf-8"?>
 <p:sld xmlns:a="http://schemas.openxmlformats.org/drawingml/2006/main" xmlns:r="http://schemas.openxmlformats.org/officeDocument/2006/relationships" xmlns:p="http://schemas.openxmlformats.org/presentationml/2006/main">
   <p:cSld>
@@ -15160,8 +15516,8 @@
         </p:nvSpPr>
         <p:spPr>
           <a:xfrm>
-            <a:off x="838200" y="365126"/>
-            <a:ext cx="10515600" cy="728384"/>
+            <a:off x="838200" y="294854"/>
+            <a:ext cx="10515600" cy="1325563"/>
           </a:xfrm>
         </p:spPr>
         <p:txBody>
@@ -15171,13 +15527,24 @@
           <a:lstStyle/>
           <a:p>
             <a:r>
-              <a:rPr sz="3600" b="1" i="0">
+              <a:rPr sz="2600" b="1" i="0">
                 <a:solidFill>
                   <a:srgbClr val="102C57"/>
                 </a:solidFill>
                 <a:latin typeface="Calibri"/>
               </a:rPr>
-              <a:t>Machine Learning Methods Used</a:t>
+              <a:t>Fraud-BERT: Transformer Based Context Aware Online Recruitment Fraud Detection</a:t>
+            </a:r>
+          </a:p>
+          <a:p>
+            <a:r>
+              <a:rPr sz="1600" b="0" i="1">
+                <a:solidFill>
+                  <a:srgbClr val="0066CC"/>
+                </a:solidFill>
+                <a:latin typeface="Calibri"/>
+              </a:rPr>
+              <a:t>DOI: 10.1007/s44425-025-00109-x  |  Discover Computing (Springer, 2025)</a:t>
             </a:r>
           </a:p>
         </p:txBody>
@@ -15194,8 +15561,8 @@
         </p:nvSpPr>
         <p:spPr>
           <a:xfrm>
-            <a:off x="838200" y="1452763"/>
-            <a:ext cx="10515600" cy="5086149"/>
+            <a:off x="838200" y="2415805"/>
+            <a:ext cx="10515600" cy="3707860"/>
           </a:xfrm>
         </p:spPr>
         <p:txBody>
@@ -15203,204 +15570,172 @@
             <a:noAutofit/>
           </a:bodyPr>
           <a:lstStyle/>
-          <a:p/>
-          <a:p>
-            <a:r>
-              <a:rPr sz="2000" b="0" i="0">
-                <a:solidFill>
-                  <a:srgbClr val="646464"/>
+          <a:p>
+            <a:pPr marL="0" indent="0">
+              <a:spcAft>
+                <a:spcPts val="1000"/>
+              </a:spcAft>
+              <a:buNone/>
+            </a:pPr>
+            <a:r>
+              <a:rPr sz="2000" b="1" i="0" dirty="0">
+                <a:solidFill>
+                  <a:srgbClr val="102C57"/>
                 </a:solidFill>
                 <a:latin typeface="Calibri"/>
               </a:rPr>
-              <a:t>The study employs:</a:t>
+              <a:t>Goal: </a:t>
+            </a:r>
+            <a:r>
+              <a:rPr sz="2000" b="0" i="0" dirty="0">
+                <a:solidFill>
+                  <a:srgbClr val="323232"/>
+                </a:solidFill>
+                <a:latin typeface="Calibri"/>
+              </a:rPr>
+              <a:t>To develop a high-accuracy, context-aware online recruitment fraud detection framework using fine-tuned BERT transformer architecture.</a:t>
+            </a:r>
+          </a:p>
+          <a:p>
+            <a:pPr marL="0" indent="0">
+              <a:spcAft>
+                <a:spcPts val="600"/>
+              </a:spcAft>
+              <a:buNone/>
+            </a:pPr>
+            <a:r>
+              <a:rPr sz="2000" b="1" i="0" dirty="0">
+                <a:solidFill>
+                  <a:srgbClr val="102C57"/>
+                </a:solidFill>
+                <a:latin typeface="Calibri"/>
+              </a:rPr>
+              <a:t>Why this study is important:</a:t>
             </a:r>
           </a:p>
           <a:p>
             <a:pPr>
               <a:spcAft>
-                <a:spcPts val="400"/>
+                <a:spcPts val="600"/>
               </a:spcAft>
             </a:pPr>
             <a:r>
-              <a:rPr sz="2000" b="1" i="0">
-                <a:solidFill>
-                  <a:srgbClr val="102C57"/>
+              <a:rPr sz="1800" b="0" i="0" dirty="0">
+                <a:solidFill>
+                  <a:srgbClr val="323232"/>
                 </a:solidFill>
                 <a:latin typeface="Calibri"/>
               </a:rPr>
-              <a:t>Fraud-BERT (Bidirectional Encoder Representations from Transformers):</a:t>
+              <a:t>Online job scams deceive vulnerable job seekers, causing severe monetary extortion, identity theft, and data compromise.</a:t>
             </a:r>
           </a:p>
           <a:p>
             <a:pPr>
               <a:spcAft>
-                <a:spcPts val="400"/>
+                <a:spcPts val="600"/>
               </a:spcAft>
             </a:pPr>
             <a:r>
-              <a:rPr sz="1700" b="0" i="0">
+              <a:rPr sz="1800" b="0" i="0" dirty="0">
                 <a:solidFill>
                   <a:srgbClr val="323232"/>
                 </a:solidFill>
                 <a:latin typeface="Calibri"/>
               </a:rPr>
-              <a:t>• Pre-trained multi-layer bidirectional Transformer encoder network (bert-base-uncased).</a:t>
+              <a:t>Traditional machine learning models (LR, SVM, RF) rely on bag-of-words or static embeddings that ignore linguistic context, word order, and polysemy.</a:t>
             </a:r>
           </a:p>
           <a:p>
             <a:pPr>
               <a:spcAft>
-                <a:spcPts val="400"/>
+                <a:spcPts val="600"/>
               </a:spcAft>
             </a:pPr>
             <a:r>
-              <a:rPr sz="1700" b="0" i="0">
+              <a:rPr sz="1800" b="0" i="0" dirty="0">
                 <a:solidFill>
                   <a:srgbClr val="323232"/>
                 </a:solidFill>
                 <a:latin typeface="Calibri"/>
               </a:rPr>
-              <a:t>• Extracts dynamic token representations via masked language modeling and next sentence objectives.</a:t>
-            </a:r>
-          </a:p>
-          <a:p>
-            <a:pPr>
-              <a:spcAft>
-                <a:spcPts val="400"/>
-              </a:spcAft>
-            </a:pPr>
-            <a:r>
-              <a:rPr sz="1700" b="0" i="0">
-                <a:solidFill>
-                  <a:srgbClr val="323232"/>
+              <a:t>Transformer-based bidirectional self-attention enables deep contextual awareness, significantly reducing false alarms and improving detection reliability on highly imbalanced job post data.</a:t>
+            </a:r>
+          </a:p>
+        </p:txBody>
+      </p:sp>
+      <p:sp>
+        <p:nvSpPr>
+          <p:cNvPr id="4" name="Slide Number Placeholder 3"/>
+          <p:cNvSpPr>
+            <a:spLocks noGrp="1"/>
+          </p:cNvSpPr>
+          <p:nvPr>
+            <p:ph type="sldNum" sz="quarter" idx="12"/>
+          </p:nvPr>
+        </p:nvSpPr>
+        <p:spPr/>
+        <p:txBody>
+          <a:bodyPr/>
+          <a:lstStyle/>
+          <a:p>
+            <a:pPr algn="r"/>
+            <a:r>
+              <a:rPr sz="1200" b="0" i="0">
+                <a:solidFill>
+                  <a:srgbClr val="787878"/>
                 </a:solidFill>
                 <a:latin typeface="Calibri"/>
               </a:rPr>
-              <a:t>• Captures full contextual dependencies from both left-to-right and right-to-left simultaneously.</a:t>
-            </a:r>
-          </a:p>
-          <a:p>
-            <a:pPr>
-              <a:spcAft>
-                <a:spcPts val="400"/>
-              </a:spcAft>
-            </a:pPr>
-            <a:r>
-              <a:rPr sz="1700" b="0" i="0">
-                <a:solidFill>
-                  <a:srgbClr val="323232"/>
+              <a:t>5</a:t>
+            </a:r>
+          </a:p>
+        </p:txBody>
+      </p:sp>
+      <p:sp>
+        <p:nvSpPr>
+          <p:cNvPr id="5" name="TextBox 4">
+            <a:extLst>
+              <a:ext uri="{FF2B5EF4-FFF2-40B4-BE49-F238E27FC236}">
+                <a16:creationId xmlns:a16="http://schemas.microsoft.com/office/drawing/2014/main" id="{321DD254-6A9D-EC5A-3C0F-9005CE174E46}"/>
+              </a:ext>
+            </a:extLst>
+          </p:cNvPr>
+          <p:cNvSpPr txBox="1"/>
+          <p:nvPr/>
+        </p:nvSpPr>
+        <p:spPr>
+          <a:xfrm>
+            <a:off x="838200" y="1620417"/>
+            <a:ext cx="3836307" cy="461665"/>
+          </a:xfrm>
+          <a:prstGeom prst="rect">
+            <a:avLst/>
+          </a:prstGeom>
+          <a:noFill/>
+        </p:spPr>
+        <p:txBody>
+          <a:bodyPr wrap="none" rtlCol="0">
+            <a:spAutoFit/>
+          </a:bodyPr>
+          <a:lstStyle/>
+          <a:p>
+            <a:r>
+              <a:rPr sz="2000" b="1" i="0">
+                <a:solidFill>
+                  <a:srgbClr val="102C57"/>
                 </a:solidFill>
                 <a:latin typeface="Calibri"/>
               </a:rPr>
-              <a:t>• Fine-tuned end-to-end with a classification head on domain-specific recruitment data.</a:t>
-            </a:r>
-          </a:p>
-          <a:p>
-            <a:pPr>
-              <a:spcAft>
-                <a:spcPts val="400"/>
-              </a:spcAft>
-            </a:pPr>
-            <a:r>
-              <a:rPr sz="2000" b="1" i="0">
-                <a:solidFill>
-                  <a:srgbClr val="102C57"/>
+              <a:t>Authors: </a:t>
+            </a:r>
+            <a:r>
+              <a:rPr sz="2000" b="0" i="0">
+                <a:solidFill>
+                  <a:srgbClr val="323232"/>
                 </a:solidFill>
                 <a:latin typeface="Calibri"/>
               </a:rPr>
-              <a:t>Transformer Architecture Components:</a:t>
-            </a:r>
-          </a:p>
-          <a:p>
-            <a:pPr>
-              <a:spcAft>
-                <a:spcPts val="400"/>
-              </a:spcAft>
-            </a:pPr>
-            <a:r>
-              <a:rPr sz="1700" b="0" i="0">
-                <a:solidFill>
-                  <a:srgbClr val="323232"/>
-                </a:solidFill>
-                <a:latin typeface="Calibri"/>
-              </a:rPr>
-              <a:t>• Input Layer: Element-wise sum of Token Embeddings, Positional Embeddings, and Segment Embeddings.</a:t>
-            </a:r>
-          </a:p>
-          <a:p>
-            <a:pPr>
-              <a:spcAft>
-                <a:spcPts val="400"/>
-              </a:spcAft>
-            </a:pPr>
-            <a:r>
-              <a:rPr sz="1700" b="0" i="0">
-                <a:solidFill>
-                  <a:srgbClr val="323232"/>
-                </a:solidFill>
-                <a:latin typeface="Calibri"/>
-              </a:rPr>
-              <a:t>• 12 Transformer Encoder Blocks: Featuring Multi-Head Self-Attention mechanisms (768 hidden dimensions).</a:t>
-            </a:r>
-          </a:p>
-          <a:p>
-            <a:pPr>
-              <a:spcAft>
-                <a:spcPts val="400"/>
-              </a:spcAft>
-            </a:pPr>
-            <a:r>
-              <a:rPr sz="1700" b="0" i="0">
-                <a:solidFill>
-                  <a:srgbClr val="323232"/>
-                </a:solidFill>
-                <a:latin typeface="Calibri"/>
-              </a:rPr>
-              <a:t>• Feed-Forward Layers: Position-wise feed-forward networks with Dropout, Layer Normalization, and Residual Connections.</a:t>
-            </a:r>
-          </a:p>
-          <a:p>
-            <a:pPr>
-              <a:spcAft>
-                <a:spcPts val="400"/>
-              </a:spcAft>
-            </a:pPr>
-            <a:r>
-              <a:rPr sz="1700" b="0" i="0">
-                <a:solidFill>
-                  <a:srgbClr val="323232"/>
-                </a:solidFill>
-                <a:latin typeface="Calibri"/>
-              </a:rPr>
-              <a:t>• Classification Head: Linear dense projection layer over the [CLS] token with Softmax probability output.</a:t>
-            </a:r>
-          </a:p>
-        </p:txBody>
-      </p:sp>
-      <p:sp>
-        <p:nvSpPr>
-          <p:cNvPr id="4" name="Slide Number Placeholder 3"/>
-          <p:cNvSpPr>
-            <a:spLocks noGrp="1"/>
-          </p:cNvSpPr>
-          <p:nvPr>
-            <p:ph type="sldNum" sz="quarter" idx="12"/>
-          </p:nvPr>
-        </p:nvSpPr>
-        <p:spPr/>
-        <p:txBody>
-          <a:bodyPr/>
-          <a:lstStyle/>
-          <a:p>
-            <a:pPr algn="r"/>
-            <a:r>
-              <a:rPr sz="1200" b="0" i="0">
-                <a:solidFill>
-                  <a:srgbClr val="787878"/>
-                </a:solidFill>
-                <a:latin typeface="Calibri"/>
-              </a:rPr>
-              <a:t>6</a:t>
+              <a:t>Khushboo Taneja, Jyoti Vashishtha, Saroj Ratnoo</a:t>
             </a:r>
           </a:p>
         </p:txBody>
@@ -15408,7 +15743,7 @@
     </p:spTree>
     <p:extLst>
       <p:ext uri="{BB962C8B-B14F-4D97-AF65-F5344CB8AC3E}">
-        <p14:creationId xmlns:p14="http://schemas.microsoft.com/office/powerpoint/2010/main" val="83254828"/>
+        <p14:creationId xmlns:p14="http://schemas.microsoft.com/office/powerpoint/2010/main" val="4093034545"/>
       </p:ext>
     </p:extLst>
   </p:cSld>
@@ -15459,8 +15794,8 @@
         </p:nvSpPr>
         <p:spPr>
           <a:xfrm>
-            <a:off x="838200" y="223724"/>
-            <a:ext cx="6646682" cy="984704"/>
+            <a:off x="838200" y="195942"/>
+            <a:ext cx="10515600" cy="970189"/>
           </a:xfrm>
         </p:spPr>
         <p:txBody>
@@ -15476,195 +15811,265 @@
                 </a:solidFill>
                 <a:latin typeface="Calibri"/>
               </a:rPr>
-              <a:t>Proposed Prediction Model Pipeline</a:t>
-            </a:r>
-          </a:p>
-        </p:txBody>
-      </p:sp>
-      <p:sp>
-        <p:nvSpPr>
-          <p:cNvPr id="3" name="Content Placeholder 2"/>
-          <p:cNvSpPr>
-            <a:spLocks noGrp="1"/>
+              <a:t>Dataset Used (EMSCAD)</a:t>
+            </a:r>
+          </a:p>
+        </p:txBody>
+      </p:sp>
+      <p:sp>
+        <p:nvSpPr>
+          <p:cNvPr id="4" name="Slide Number Placeholder 3"/>
+          <p:cNvSpPr>
+            <a:spLocks noGrp="1"/>
+          </p:cNvSpPr>
+          <p:nvPr>
+            <p:ph type="sldNum" sz="quarter" idx="12"/>
+          </p:nvPr>
+        </p:nvSpPr>
+        <p:spPr/>
+        <p:txBody>
+          <a:bodyPr/>
+          <a:lstStyle/>
+          <a:p>
+            <a:pPr algn="r"/>
+            <a:r>
+              <a:rPr sz="1200" b="0" i="0">
+                <a:solidFill>
+                  <a:srgbClr val="787878"/>
+                </a:solidFill>
+                <a:latin typeface="Calibri"/>
+              </a:rPr>
+              <a:t>8</a:t>
+            </a:r>
+          </a:p>
+        </p:txBody>
+      </p:sp>
+      <p:sp>
+        <p:nvSpPr>
+          <p:cNvPr id="5" name="Rectangle 1">
+            <a:extLst>
+              <a:ext uri="{FF2B5EF4-FFF2-40B4-BE49-F238E27FC236}">
+                <a16:creationId xmlns:a16="http://schemas.microsoft.com/office/drawing/2014/main" id="{212F6842-8552-FC78-4FA9-1028AA412F73}"/>
+              </a:ext>
+            </a:extLst>
+          </p:cNvPr>
+          <p:cNvSpPr>
+            <a:spLocks noGrp="1" noChangeArrowheads="1"/>
           </p:cNvSpPr>
           <p:nvPr>
             <p:ph idx="1"/>
           </p:nvPr>
         </p:nvSpPr>
-        <p:spPr>
+        <p:spPr bwMode="auto">
           <a:xfrm>
-            <a:off x="838200" y="1309835"/>
-            <a:ext cx="10515600" cy="5046515"/>
+            <a:off x="838200" y="1519152"/>
+            <a:ext cx="9057640" cy="4172937"/>
           </a:xfrm>
+          <a:prstGeom prst="rect">
+            <a:avLst/>
+          </a:prstGeom>
+          <a:noFill/>
+          <a:ln>
+            <a:noFill/>
+          </a:ln>
+          <a:effectLst/>
+          <a:extLst>
+            <a:ext uri="{909E8E84-426E-40DD-AFC4-6F175D3DCCD1}">
+              <a14:hiddenFill xmlns:a14="http://schemas.microsoft.com/office/drawing/2010/main">
+                <a:solidFill>
+                  <a:schemeClr val="accent1"/>
+                </a:solidFill>
+              </a14:hiddenFill>
+            </a:ext>
+            <a:ext uri="{91240B29-F687-4F45-9708-019B960494DF}">
+              <a14:hiddenLine xmlns:a14="http://schemas.microsoft.com/office/drawing/2010/main" w="9525">
+                <a:solidFill>
+                  <a:schemeClr val="tx1"/>
+                </a:solidFill>
+                <a:miter lim="800000"/>
+                <a:headEnd/>
+                <a:tailEnd/>
+              </a14:hiddenLine>
+            </a:ext>
+            <a:ext uri="{AF507438-7753-43E0-B8FC-AC1667EBCBE1}">
+              <a14:hiddenEffects xmlns:a14="http://schemas.microsoft.com/office/drawing/2010/main">
+                <a:effectLst>
+                  <a:outerShdw dist="35921" dir="2700000" algn="ctr" rotWithShape="0">
+                    <a:schemeClr val="bg2"/>
+                  </a:outerShdw>
+                </a:effectLst>
+              </a14:hiddenEffects>
+            </a:ext>
+          </a:extLst>
         </p:spPr>
         <p:txBody>
-          <a:bodyPr>
-            <a:normAutofit/>
+          <a:bodyPr vert="horz" wrap="square" lIns="91440" tIns="45720" rIns="91440" bIns="45720" numCol="1" anchor="ctr" anchorCtr="0" compatLnSpc="1">
+            <a:prstTxWarp prst="textNoShape">
+              <a:avLst/>
+            </a:prstTxWarp>
+            <a:spAutoFit/>
           </a:bodyPr>
           <a:lstStyle/>
-          <a:p/>
-          <a:p>
-            <a:r>
-              <a:rPr sz="2000" b="0" i="0">
-                <a:solidFill>
-                  <a:srgbClr val="646464"/>
+          <a:p>
+            <a:pPr marL="0" indent="0" algn="just">
+              <a:spcAft>
+                <a:spcPts val="800"/>
+              </a:spcAft>
+              <a:buNone/>
+            </a:pPr>
+            <a:r>
+              <a:rPr sz="2000" b="1" i="0" dirty="0">
+                <a:solidFill>
+                  <a:srgbClr val="102C57"/>
                 </a:solidFill>
                 <a:latin typeface="Calibri"/>
               </a:rPr>
-              <a:t>The prediction framework operates across 5 structured stages:</a:t>
-            </a:r>
-          </a:p>
-          <a:p>
-            <a:pPr>
-              <a:spcAft>
-                <a:spcPts val="500"/>
-              </a:spcAft>
-            </a:pPr>
-            <a:r>
-              <a:rPr sz="1700" b="1" i="0">
-                <a:solidFill>
-                  <a:srgbClr val="102C57"/>
+              <a:t>Benchmark Source: </a:t>
+            </a:r>
+            <a:r>
+              <a:rPr sz="1900" b="0" i="0" dirty="0">
+                <a:solidFill>
+                  <a:srgbClr val="323232"/>
                 </a:solidFill>
                 <a:latin typeface="Calibri"/>
               </a:rPr>
-              <a:t>• Stage 1: Data Preprocessing &amp; Tokenization: </a:t>
-            </a:r>
-            <a:r>
-              <a:rPr sz="1700" b="0" i="0">
-                <a:solidFill>
-                  <a:srgbClr val="323232"/>
+              <a:t>Employment Scam Aegean Dataset (EMSCAD) / Kaggle Repository (University of the Aegean)</a:t>
+            </a:r>
+          </a:p>
+          <a:p>
+            <a:pPr marL="0" indent="0" algn="just">
+              <a:spcAft>
+                <a:spcPts val="400"/>
+              </a:spcAft>
+              <a:buNone/>
+            </a:pPr>
+            <a:r>
+              <a:rPr sz="2000" b="1" i="0" dirty="0">
+                <a:solidFill>
+                  <a:srgbClr val="102C57"/>
                 </a:solidFill>
                 <a:latin typeface="Calibri"/>
               </a:rPr>
-              <a:t>Text normalization, noise &amp; HTML tag cleaning, and WordPiece tokenization with a sequence length of 512 tokens.</a:t>
-            </a:r>
-          </a:p>
-          <a:p>
-            <a:pPr>
+              <a:t>Dataset Characteristics:</a:t>
+            </a:r>
+          </a:p>
+          <a:p>
+            <a:pPr marL="457200" lvl="1" indent="0" algn="just">
               <a:spcAft>
-                <a:spcPts val="500"/>
+                <a:spcPts val="400"/>
               </a:spcAft>
+              <a:buNone/>
             </a:pPr>
             <a:r>
-              <a:rPr sz="1700" b="1" i="0">
-                <a:solidFill>
-                  <a:srgbClr val="102C57"/>
+              <a:rPr sz="1700" b="0" i="0" dirty="0">
+                <a:solidFill>
+                  <a:srgbClr val="323232"/>
                 </a:solidFill>
                 <a:latin typeface="Calibri"/>
               </a:rPr>
-              <a:t>• Stage 2: Contextual Representation Extraction: </a:t>
-            </a:r>
-            <a:r>
-              <a:rPr sz="1700" b="0" i="0">
+              <a:t>• Contains 17,880 real-world job advertisement records collected from 2012 to 2014.</a:t>
+            </a:r>
+          </a:p>
+          <a:p>
+            <a:pPr marL="457200" lvl="1" indent="0" algn="just">
+              <a:spcAft>
+                <a:spcPts val="400"/>
+              </a:spcAft>
+              <a:buNone/>
+            </a:pPr>
+            <a:r>
+              <a:rPr sz="1700" b="0" i="0" dirty="0">
                 <a:solidFill>
                   <a:srgbClr val="323232"/>
                 </a:solidFill>
                 <a:latin typeface="Calibri"/>
               </a:rPr>
-              <a:t>Passing token IDs through 12 transformer encoder blocks to generate 768-dimensional bidirectional contextual embeddings.</a:t>
-            </a:r>
-          </a:p>
-          <a:p>
-            <a:pPr>
+              <a:t>• Rich Textual Attributes: Job Title, Company Profile, Description, Requirements, and Benefits.</a:t>
+            </a:r>
+          </a:p>
+          <a:p>
+            <a:pPr marL="457200" lvl="1" indent="0" algn="just">
               <a:spcAft>
-                <a:spcPts val="500"/>
+                <a:spcPts val="400"/>
               </a:spcAft>
+              <a:buNone/>
             </a:pPr>
             <a:r>
-              <a:rPr sz="1700" b="1" i="0">
-                <a:solidFill>
-                  <a:srgbClr val="102C57"/>
+              <a:rPr sz="1700" b="0" i="0" dirty="0">
+                <a:solidFill>
+                  <a:srgbClr val="323232"/>
                 </a:solidFill>
                 <a:latin typeface="Calibri"/>
               </a:rPr>
-              <a:t>• Stage 3: Model Fine-Tuning &amp; Optimization: </a:t>
-            </a:r>
-            <a:r>
-              <a:rPr sz="1700" b="0" i="0">
-                <a:solidFill>
-                  <a:srgbClr val="323232"/>
+              <a:t>• Categorical &amp; Metadata Features: Telecommuting, Has Company Logo, Has Screening Questions, Employment Type, Required Experience, and Education.</a:t>
+            </a:r>
+          </a:p>
+          <a:p>
+            <a:pPr marL="0" indent="0" algn="just">
+              <a:spcAft>
+                <a:spcPts val="400"/>
+              </a:spcAft>
+              <a:buNone/>
+            </a:pPr>
+            <a:r>
+              <a:rPr sz="2000" b="1" i="0" dirty="0">
+                <a:solidFill>
+                  <a:srgbClr val="102C57"/>
                 </a:solidFill>
                 <a:latin typeface="Calibri"/>
               </a:rPr>
-              <a:t>Fine-tuning Fraud-BERT end-to-end using the AdamW optimizer with weight decay, linear warmup, and binary cross-entropy loss.</a:t>
-            </a:r>
-          </a:p>
-          <a:p>
-            <a:pPr>
+              <a:t>Target Class Distribution (Severe Real-World Imbalance):</a:t>
+            </a:r>
+          </a:p>
+          <a:p>
+            <a:pPr marL="457200" lvl="1" indent="0" algn="just">
               <a:spcAft>
-                <a:spcPts val="500"/>
+                <a:spcPts val="400"/>
               </a:spcAft>
+              <a:buNone/>
             </a:pPr>
             <a:r>
-              <a:rPr sz="1700" b="1" i="0">
-                <a:solidFill>
-                  <a:srgbClr val="102C57"/>
+              <a:rPr sz="1700" b="0" i="0" dirty="0">
+                <a:solidFill>
+                  <a:srgbClr val="323232"/>
                 </a:solidFill>
                 <a:latin typeface="Calibri"/>
               </a:rPr>
-              <a:t>• Stage 4: Prediction &amp; Classification Inference: </a:t>
-            </a:r>
-            <a:r>
-              <a:rPr sz="1700" b="0" i="0">
+              <a:t>• Class 0 (Legitimate Postings): 17,014 samples (~ 95.16%)</a:t>
+            </a:r>
+          </a:p>
+          <a:p>
+            <a:pPr marL="457200" lvl="1" indent="0" algn="just">
+              <a:spcAft>
+                <a:spcPts val="400"/>
+              </a:spcAft>
+              <a:buNone/>
+            </a:pPr>
+            <a:r>
+              <a:rPr sz="1700" b="0" i="0" dirty="0">
                 <a:solidFill>
                   <a:srgbClr val="323232"/>
                 </a:solidFill>
                 <a:latin typeface="Calibri"/>
               </a:rPr>
-              <a:t>Extracting the [CLS] special token vector and projecting through a dense classification head to output class probabilities (0 = Legitimate, 1 = Fraudulent).</a:t>
-            </a:r>
-          </a:p>
-          <a:p>
-            <a:pPr>
+              <a:t>• Class 1 (Fraudulent Postings): 866 samples (~ 4.84%)</a:t>
+            </a:r>
+          </a:p>
+          <a:p>
+            <a:pPr marL="457200" lvl="1" indent="0" algn="just">
               <a:spcAft>
-                <a:spcPts val="500"/>
+                <a:spcPts val="400"/>
               </a:spcAft>
+              <a:buNone/>
             </a:pPr>
             <a:r>
-              <a:rPr sz="1700" b="1" i="0">
-                <a:solidFill>
-                  <a:srgbClr val="102C57"/>
+              <a:rPr sz="1700" b="0" i="0" dirty="0">
+                <a:solidFill>
+                  <a:srgbClr val="323232"/>
                 </a:solidFill>
                 <a:latin typeface="Calibri"/>
               </a:rPr>
-              <a:t>• Stage 5: Multi-Metric Performance Evaluation: </a:t>
-            </a:r>
-            <a:r>
-              <a:rPr sz="1700" b="0" i="0">
-                <a:solidFill>
-                  <a:srgbClr val="323232"/>
-                </a:solidFill>
-                <a:latin typeface="Calibri"/>
-              </a:rPr>
-              <a:t>Comprehensive evaluation using Accuracy, Macro Precision, Macro Recall, Macro F1-Score, and ROC-AUC metrics.</a:t>
-            </a:r>
-          </a:p>
-        </p:txBody>
-      </p:sp>
-      <p:sp>
-        <p:nvSpPr>
-          <p:cNvPr id="4" name="Slide Number Placeholder 3"/>
-          <p:cNvSpPr>
-            <a:spLocks noGrp="1"/>
-          </p:cNvSpPr>
-          <p:nvPr>
-            <p:ph type="sldNum" sz="quarter" idx="12"/>
-          </p:nvPr>
-        </p:nvSpPr>
-        <p:spPr/>
-        <p:txBody>
-          <a:bodyPr/>
-          <a:lstStyle/>
-          <a:p>
-            <a:pPr algn="r"/>
-            <a:r>
-              <a:rPr sz="1200" b="0" i="0">
-                <a:solidFill>
-                  <a:srgbClr val="787878"/>
-                </a:solidFill>
-                <a:latin typeface="Calibri"/>
-              </a:rPr>
-              <a:t>7</a:t>
+              <a:t>• Imbalance Challenge: Due to the high class skew, macro-averaged metrics (Macro F1 &amp; ROC-AUC) are mandatory to prevent majority-class bias.</a:t>
             </a:r>
           </a:p>
         </p:txBody>
@@ -15672,7 +16077,7 @@
     </p:spTree>
     <p:extLst>
       <p:ext uri="{BB962C8B-B14F-4D97-AF65-F5344CB8AC3E}">
-        <p14:creationId xmlns:p14="http://schemas.microsoft.com/office/powerpoint/2010/main" val="588085132"/>
+        <p14:creationId xmlns:p14="http://schemas.microsoft.com/office/powerpoint/2010/main" val="2694603038"/>
       </p:ext>
     </p:extLst>
   </p:cSld>
@@ -15723,8 +16128,8 @@
         </p:nvSpPr>
         <p:spPr>
           <a:xfrm>
-            <a:off x="838200" y="195942"/>
-            <a:ext cx="10515600" cy="970189"/>
+            <a:off x="838200" y="365126"/>
+            <a:ext cx="10515600" cy="728384"/>
           </a:xfrm>
         </p:spPr>
         <p:txBody>
@@ -15740,257 +16145,284 @@
                 </a:solidFill>
                 <a:latin typeface="Calibri"/>
               </a:rPr>
-              <a:t>Dataset Used (EMSCAD)</a:t>
-            </a:r>
-          </a:p>
-        </p:txBody>
-      </p:sp>
-      <p:sp>
-        <p:nvSpPr>
-          <p:cNvPr id="4" name="Slide Number Placeholder 3"/>
-          <p:cNvSpPr>
-            <a:spLocks noGrp="1"/>
-          </p:cNvSpPr>
-          <p:nvPr>
-            <p:ph type="sldNum" sz="quarter" idx="12"/>
-          </p:nvPr>
-        </p:nvSpPr>
-        <p:spPr/>
-        <p:txBody>
-          <a:bodyPr/>
+              <a:t>Machine Learning Methods Used</a:t>
+            </a:r>
+          </a:p>
+        </p:txBody>
+      </p:sp>
+      <p:sp>
+        <p:nvSpPr>
+          <p:cNvPr id="3" name="Content Placeholder 2"/>
+          <p:cNvSpPr>
+            <a:spLocks noGrp="1"/>
+          </p:cNvSpPr>
+          <p:nvPr>
+            <p:ph idx="1"/>
+          </p:nvPr>
+        </p:nvSpPr>
+        <p:spPr>
+          <a:xfrm>
+            <a:off x="838200" y="1093510"/>
+            <a:ext cx="10515600" cy="5086149"/>
+          </a:xfrm>
+        </p:spPr>
+        <p:txBody>
+          <a:bodyPr>
+            <a:noAutofit/>
+          </a:bodyPr>
           <a:lstStyle/>
           <a:p>
-            <a:pPr algn="r"/>
-            <a:r>
-              <a:rPr sz="1200" b="0" i="0">
-                <a:solidFill>
-                  <a:srgbClr val="787878"/>
+            <a:pPr marL="0" indent="0">
+              <a:buNone/>
+            </a:pPr>
+            <a:endParaRPr lang="en-US" dirty="0"/>
+          </a:p>
+          <a:p>
+            <a:pPr marL="0" indent="0">
+              <a:buNone/>
+            </a:pPr>
+            <a:r>
+              <a:rPr sz="2000" b="0" i="0" dirty="0">
+                <a:solidFill>
+                  <a:srgbClr val="646464"/>
                 </a:solidFill>
                 <a:latin typeface="Calibri"/>
               </a:rPr>
-              <a:t>8</a:t>
-            </a:r>
-          </a:p>
-        </p:txBody>
-      </p:sp>
-      <p:sp>
-        <p:nvSpPr>
-          <p:cNvPr id="5" name="Rectangle 1">
-            <a:extLst>
-              <a:ext uri="{FF2B5EF4-FFF2-40B4-BE49-F238E27FC236}">
-                <a16:creationId xmlns:a16="http://schemas.microsoft.com/office/drawing/2014/main" id="{212F6842-8552-FC78-4FA9-1028AA412F73}"/>
-              </a:ext>
-            </a:extLst>
-          </p:cNvPr>
-          <p:cNvSpPr>
-            <a:spLocks noGrp="1" noChangeArrowheads="1"/>
-          </p:cNvSpPr>
-          <p:nvPr>
-            <p:ph idx="1"/>
-          </p:nvPr>
-        </p:nvSpPr>
-        <p:spPr bwMode="auto">
-          <a:xfrm>
-            <a:off x="838200" y="1301121"/>
-            <a:ext cx="8032423" cy="5401479"/>
-          </a:xfrm>
-          <a:prstGeom prst="rect">
-            <a:avLst/>
-          </a:prstGeom>
-          <a:noFill/>
-          <a:ln>
-            <a:noFill/>
-          </a:ln>
-          <a:effectLst/>
-          <a:extLst>
-            <a:ext uri="{909E8E84-426E-40DD-AFC4-6F175D3DCCD1}">
-              <a14:hiddenFill xmlns:a14="http://schemas.microsoft.com/office/drawing/2010/main">
-                <a:solidFill>
-                  <a:schemeClr val="accent1"/>
-                </a:solidFill>
-              </a14:hiddenFill>
-            </a:ext>
-            <a:ext uri="{91240B29-F687-4F45-9708-019B960494DF}">
-              <a14:hiddenLine xmlns:a14="http://schemas.microsoft.com/office/drawing/2010/main" w="9525">
-                <a:solidFill>
-                  <a:schemeClr val="tx1"/>
-                </a:solidFill>
-                <a:miter lim="800000"/>
-                <a:headEnd/>
-                <a:tailEnd/>
-              </a14:hiddenLine>
-            </a:ext>
-            <a:ext uri="{AF507438-7753-43E0-B8FC-AC1667EBCBE1}">
-              <a14:hiddenEffects xmlns:a14="http://schemas.microsoft.com/office/drawing/2010/main">
-                <a:effectLst>
-                  <a:outerShdw dist="35921" dir="2700000" algn="ctr" rotWithShape="0">
-                    <a:schemeClr val="bg2"/>
-                  </a:outerShdw>
-                </a:effectLst>
-              </a14:hiddenEffects>
-            </a:ext>
-          </a:extLst>
-        </p:spPr>
-        <p:txBody>
-          <a:bodyPr vert="horz" wrap="square" lIns="91440" tIns="45720" rIns="91440" bIns="45720" numCol="1" anchor="ctr" anchorCtr="0" compatLnSpc="1">
-            <a:prstTxWarp prst="textNoShape">
-              <a:avLst/>
-            </a:prstTxWarp>
-            <a:spAutoFit/>
-          </a:bodyPr>
-          <a:lstStyle/>
-          <a:p/>
-          <a:p>
-            <a:pPr>
-              <a:spcAft>
-                <a:spcPts val="800"/>
-              </a:spcAft>
-            </a:pPr>
-            <a:r>
-              <a:rPr sz="2000" b="1" i="0">
-                <a:solidFill>
-                  <a:srgbClr val="102C57"/>
-                </a:solidFill>
-                <a:latin typeface="Calibri"/>
-              </a:rPr>
-              <a:t>Benchmark Source: </a:t>
-            </a:r>
-            <a:r>
-              <a:rPr sz="1900" b="0" i="0">
-                <a:solidFill>
-                  <a:srgbClr val="323232"/>
-                </a:solidFill>
-                <a:latin typeface="Calibri"/>
-              </a:rPr>
-              <a:t>Employment Scam Aegean Dataset (EMSCAD) / Kaggle Repository (University of the Aegean)</a:t>
-            </a:r>
-          </a:p>
-          <a:p>
-            <a:pPr>
+              <a:t>The study employs:</a:t>
+            </a:r>
+          </a:p>
+          <a:p>
+            <a:pPr marL="0" indent="0">
               <a:spcAft>
                 <a:spcPts val="400"/>
               </a:spcAft>
+              <a:buNone/>
             </a:pPr>
             <a:r>
-              <a:rPr sz="2000" b="1" i="0">
+              <a:rPr sz="2000" b="1" i="0" dirty="0">
                 <a:solidFill>
                   <a:srgbClr val="102C57"/>
                 </a:solidFill>
                 <a:latin typeface="Calibri"/>
               </a:rPr>
-              <a:t>Dataset Characteristics:</a:t>
-            </a:r>
-          </a:p>
-          <a:p>
-            <a:pPr>
+              <a:t>Fraud-BERT (Bidirectional Encoder Representations from Transformers):</a:t>
+            </a:r>
+          </a:p>
+          <a:p>
+            <a:pPr marL="457200" lvl="1" indent="0">
               <a:spcAft>
                 <a:spcPts val="400"/>
               </a:spcAft>
+              <a:buNone/>
             </a:pPr>
             <a:r>
-              <a:rPr sz="1700" b="0" i="0">
+              <a:rPr sz="1700" b="0" i="0" dirty="0">
                 <a:solidFill>
                   <a:srgbClr val="323232"/>
                 </a:solidFill>
                 <a:latin typeface="Calibri"/>
               </a:rPr>
-              <a:t>• Contains 17,880 real-world job advertisement records collected from 2012 to 2014.</a:t>
-            </a:r>
-          </a:p>
-          <a:p>
-            <a:pPr>
+              <a:t>• Pre-trained multi-layer bidirectional Transformer encoder network (</a:t>
+            </a:r>
+            <a:r>
+              <a:rPr sz="1700" b="0" i="0" dirty="0" err="1">
+                <a:solidFill>
+                  <a:srgbClr val="323232"/>
+                </a:solidFill>
+                <a:latin typeface="Calibri"/>
+              </a:rPr>
+              <a:t>bert</a:t>
+            </a:r>
+            <a:r>
+              <a:rPr sz="1700" b="0" i="0" dirty="0">
+                <a:solidFill>
+                  <a:srgbClr val="323232"/>
+                </a:solidFill>
+                <a:latin typeface="Calibri"/>
+              </a:rPr>
+              <a:t>-base-uncased).</a:t>
+            </a:r>
+          </a:p>
+          <a:p>
+            <a:pPr marL="457200" lvl="1" indent="0">
               <a:spcAft>
                 <a:spcPts val="400"/>
               </a:spcAft>
+              <a:buNone/>
             </a:pPr>
             <a:r>
-              <a:rPr sz="1700" b="0" i="0">
+              <a:rPr sz="1700" b="0" i="0" dirty="0">
                 <a:solidFill>
                   <a:srgbClr val="323232"/>
                 </a:solidFill>
                 <a:latin typeface="Calibri"/>
               </a:rPr>
-              <a:t>• Rich Textual Attributes: Job Title, Company Profile, Description, Requirements, and Benefits.</a:t>
-            </a:r>
-          </a:p>
-          <a:p>
-            <a:pPr>
+              <a:t>• Extracts dynamic token representations via masked language modeling and next sentence objectives.</a:t>
+            </a:r>
+          </a:p>
+          <a:p>
+            <a:pPr marL="457200" lvl="1" indent="0">
               <a:spcAft>
                 <a:spcPts val="400"/>
               </a:spcAft>
+              <a:buNone/>
             </a:pPr>
             <a:r>
-              <a:rPr sz="1700" b="0" i="0">
+              <a:rPr sz="1700" b="0" i="0" dirty="0">
                 <a:solidFill>
                   <a:srgbClr val="323232"/>
                 </a:solidFill>
                 <a:latin typeface="Calibri"/>
               </a:rPr>
-              <a:t>• Categorical &amp; Metadata Features: Telecommuting, Has Company Logo, Has Screening Questions, Employment Type, Required Experience, and Education.</a:t>
-            </a:r>
-          </a:p>
-          <a:p>
-            <a:pPr>
+              <a:t>• Captures full contextual dependencies from both left-to-right and right-to-left simultaneously.</a:t>
+            </a:r>
+          </a:p>
+          <a:p>
+            <a:pPr marL="457200" lvl="1" indent="0">
               <a:spcAft>
                 <a:spcPts val="400"/>
               </a:spcAft>
+              <a:buNone/>
             </a:pPr>
             <a:r>
-              <a:rPr sz="2000" b="1" i="0">
-                <a:solidFill>
-                  <a:srgbClr val="102C57"/>
+              <a:rPr sz="1700" b="0" i="0" dirty="0">
+                <a:solidFill>
+                  <a:srgbClr val="323232"/>
                 </a:solidFill>
                 <a:latin typeface="Calibri"/>
               </a:rPr>
-              <a:t>Target Class Distribution (Severe Real-World Imbalance):</a:t>
-            </a:r>
-          </a:p>
-          <a:p>
-            <a:pPr>
+              <a:t>• Fine-tuned end-to-end with a classification head on domain-specific recruitment data.</a:t>
+            </a:r>
+          </a:p>
+          <a:p>
+            <a:pPr marL="0" indent="0">
               <a:spcAft>
                 <a:spcPts val="400"/>
               </a:spcAft>
+              <a:buNone/>
             </a:pPr>
             <a:r>
-              <a:rPr sz="1700" b="0" i="0">
-                <a:solidFill>
-                  <a:srgbClr val="323232"/>
+              <a:rPr sz="2000" b="1" i="0" dirty="0">
+                <a:solidFill>
+                  <a:srgbClr val="102C57"/>
                 </a:solidFill>
                 <a:latin typeface="Calibri"/>
               </a:rPr>
-              <a:t>• Class 0 (Legitimate Postings): 17,014 samples (~ 95.16%)</a:t>
-            </a:r>
-          </a:p>
-          <a:p>
-            <a:pPr>
+              <a:t>Transformer Architecture Components:</a:t>
+            </a:r>
+          </a:p>
+          <a:p>
+            <a:pPr marL="457200" lvl="1" indent="0">
               <a:spcAft>
                 <a:spcPts val="400"/>
               </a:spcAft>
+              <a:buNone/>
             </a:pPr>
             <a:r>
-              <a:rPr sz="1700" b="0" i="0">
+              <a:rPr lang="en-IN" sz="1700" b="0" i="0" dirty="0">
                 <a:solidFill>
                   <a:srgbClr val="323232"/>
                 </a:solidFill>
                 <a:latin typeface="Calibri"/>
               </a:rPr>
-              <a:t>• Class 1 (Fraudulent Postings): 866 samples (~ 4.84%)</a:t>
-            </a:r>
-          </a:p>
-          <a:p>
-            <a:pPr>
+              <a:t>• Input Layer: Element-wise sum of Token Embeddings, Positional Embeddings, and Segment Embeddings.</a:t>
+            </a:r>
+          </a:p>
+          <a:p>
+            <a:pPr marL="457200" lvl="1" indent="0">
               <a:spcAft>
                 <a:spcPts val="400"/>
               </a:spcAft>
+              <a:buNone/>
             </a:pPr>
             <a:r>
-              <a:rPr sz="1700" b="0" i="0">
+              <a:rPr lang="en-IN" sz="1700" b="0" i="0" dirty="0">
                 <a:solidFill>
                   <a:srgbClr val="323232"/>
                 </a:solidFill>
                 <a:latin typeface="Calibri"/>
               </a:rPr>
-              <a:t>• Imbalance Challenge: Due to the high class skew, macro-averaged metrics (Macro F1 &amp; ROC-AUC) are mandatory to prevent majority-class bias.</a:t>
+              <a:t>• 12 Transformer Encoder Blocks: Featuring Multi-Head Self-Attention mechanisms (768 hidden dimensions).</a:t>
+            </a:r>
+          </a:p>
+          <a:p>
+            <a:pPr marL="457200" lvl="1" indent="0">
+              <a:spcAft>
+                <a:spcPts val="400"/>
+              </a:spcAft>
+              <a:buNone/>
+            </a:pPr>
+            <a:r>
+              <a:rPr lang="en-IN" sz="1700" b="0" i="0" dirty="0">
+                <a:solidFill>
+                  <a:srgbClr val="323232"/>
+                </a:solidFill>
+                <a:latin typeface="Calibri"/>
+              </a:rPr>
+              <a:t>• Feed-Forward Layers: Position-wise feed-forward networks with Dropout, Layer Normalization, and Residual Connections.</a:t>
+            </a:r>
+          </a:p>
+          <a:p>
+            <a:pPr marL="457200" lvl="1" indent="0">
+              <a:spcAft>
+                <a:spcPts val="400"/>
+              </a:spcAft>
+              <a:buNone/>
+            </a:pPr>
+            <a:r>
+              <a:rPr lang="en-IN" sz="1700" b="0" i="0" dirty="0">
+                <a:solidFill>
+                  <a:srgbClr val="323232"/>
+                </a:solidFill>
+                <a:latin typeface="Calibri"/>
+              </a:rPr>
+              <a:t>• Classification Head: Linear dense projection layer over the [CLS] token with </a:t>
+            </a:r>
+            <a:r>
+              <a:rPr lang="en-IN" sz="1700" b="0" i="0" dirty="0" err="1">
+                <a:solidFill>
+                  <a:srgbClr val="323232"/>
+                </a:solidFill>
+                <a:latin typeface="Calibri"/>
+              </a:rPr>
+              <a:t>Softmax</a:t>
+            </a:r>
+            <a:r>
+              <a:rPr lang="en-IN" sz="1700" b="0" i="0" dirty="0">
+                <a:solidFill>
+                  <a:srgbClr val="323232"/>
+                </a:solidFill>
+                <a:latin typeface="Calibri"/>
+              </a:rPr>
+              <a:t> probability output.</a:t>
+            </a:r>
+          </a:p>
+        </p:txBody>
+      </p:sp>
+      <p:sp>
+        <p:nvSpPr>
+          <p:cNvPr id="4" name="Slide Number Placeholder 3"/>
+          <p:cNvSpPr>
+            <a:spLocks noGrp="1"/>
+          </p:cNvSpPr>
+          <p:nvPr>
+            <p:ph type="sldNum" sz="quarter" idx="12"/>
+          </p:nvPr>
+        </p:nvSpPr>
+        <p:spPr/>
+        <p:txBody>
+          <a:bodyPr/>
+          <a:lstStyle/>
+          <a:p>
+            <a:pPr algn="r"/>
+            <a:r>
+              <a:rPr sz="1200" b="0" i="0">
+                <a:solidFill>
+                  <a:srgbClr val="787878"/>
+                </a:solidFill>
+                <a:latin typeface="Calibri"/>
+              </a:rPr>
+              <a:t>6</a:t>
             </a:r>
           </a:p>
         </p:txBody>
@@ -15998,7 +16430,7 @@
     </p:spTree>
     <p:extLst>
       <p:ext uri="{BB962C8B-B14F-4D97-AF65-F5344CB8AC3E}">
-        <p14:creationId xmlns:p14="http://schemas.microsoft.com/office/powerpoint/2010/main" val="2694603038"/>
+        <p14:creationId xmlns:p14="http://schemas.microsoft.com/office/powerpoint/2010/main" val="83254828"/>
       </p:ext>
     </p:extLst>
   </p:cSld>
@@ -16049,8 +16481,8 @@
         </p:nvSpPr>
         <p:spPr>
           <a:xfrm>
-            <a:off x="838200" y="299138"/>
-            <a:ext cx="6404429" cy="926645"/>
+            <a:off x="838200" y="223724"/>
+            <a:ext cx="7655560" cy="984704"/>
           </a:xfrm>
         </p:spPr>
         <p:txBody>
@@ -16060,13 +16492,13 @@
           <a:lstStyle/>
           <a:p>
             <a:r>
-              <a:rPr sz="3600" b="1" i="0">
+              <a:rPr sz="3600" b="1" i="0" dirty="0">
                 <a:solidFill>
                   <a:srgbClr val="102C57"/>
                 </a:solidFill>
                 <a:latin typeface="Calibri"/>
               </a:rPr>
-              <a:t>Results &amp; Performance Analysis</a:t>
+              <a:t>Proposed Prediction Model Pipeline</a:t>
             </a:r>
           </a:p>
         </p:txBody>
@@ -16083,8 +16515,8 @@
         </p:nvSpPr>
         <p:spPr>
           <a:xfrm>
-            <a:off x="838200" y="1582057"/>
-            <a:ext cx="10515600" cy="4594906"/>
+            <a:off x="838200" y="1309835"/>
+            <a:ext cx="10515600" cy="5046515"/>
           </a:xfrm>
         </p:spPr>
         <p:txBody>
@@ -16092,244 +16524,212 @@
             <a:normAutofit/>
           </a:bodyPr>
           <a:lstStyle/>
-          <a:p/>
-          <a:p>
-            <a:pPr>
-              <a:spcAft>
-                <a:spcPts val="800"/>
-              </a:spcAft>
+          <a:p>
+            <a:pPr marL="0" indent="0" algn="just">
+              <a:buNone/>
             </a:pPr>
             <a:r>
-              <a:rPr sz="2000" b="1" i="0">
-                <a:solidFill>
-                  <a:srgbClr val="102C57"/>
+              <a:rPr sz="2000" b="0" i="0" dirty="0">
+                <a:solidFill>
+                  <a:srgbClr val="646464"/>
                 </a:solidFill>
                 <a:latin typeface="Calibri"/>
               </a:rPr>
-              <a:t>Fraud-BERT achieved state-of-the-art results on the EMSCAD benchmark:</a:t>
-            </a:r>
-          </a:p>
-          <a:p>
-            <a:pPr>
+              <a:t>The prediction framework operates across 5 structured stages:</a:t>
+            </a:r>
+          </a:p>
+          <a:p>
+            <a:pPr marL="0" indent="0" algn="just">
               <a:spcAft>
                 <a:spcPts val="500"/>
               </a:spcAft>
+              <a:buNone/>
             </a:pPr>
             <a:r>
-              <a:rPr sz="1800" b="1" i="0">
-                <a:solidFill>
-                  <a:srgbClr val="323232"/>
+              <a:rPr sz="1700" b="1" i="0" dirty="0">
+                <a:solidFill>
+                  <a:srgbClr val="102C57"/>
                 </a:solidFill>
                 <a:latin typeface="Calibri"/>
               </a:rPr>
-              <a:t>• Overall Classification Accuracy: </a:t>
-            </a:r>
-            <a:r>
-              <a:rPr sz="1800" b="1" i="0">
-                <a:solidFill>
-                  <a:srgbClr val="102C57"/>
+              <a:t>• Stage 1: Data Preprocessing &amp; Tokenization: </a:t>
+            </a:r>
+            <a:r>
+              <a:rPr sz="1700" b="0" i="0" dirty="0">
+                <a:solidFill>
+                  <a:srgbClr val="323232"/>
                 </a:solidFill>
                 <a:latin typeface="Calibri"/>
               </a:rPr>
-              <a:t>99.0% (0.99) </a:t>
-            </a:r>
-            <a:r>
-              <a:rPr sz="1600" b="0" i="1">
-                <a:solidFill>
-                  <a:srgbClr val="505050"/>
+              <a:t>Text normalization, noise &amp; HTML tag cleaning, and </a:t>
+            </a:r>
+            <a:r>
+              <a:rPr sz="1700" b="0" i="0" dirty="0" err="1">
+                <a:solidFill>
+                  <a:srgbClr val="323232"/>
                 </a:solidFill>
                 <a:latin typeface="Calibri"/>
               </a:rPr>
-              <a:t>(Near-flawless classification across the complete test partition.)</a:t>
-            </a:r>
-          </a:p>
-          <a:p>
-            <a:pPr>
+              <a:t>WordPiece</a:t>
+            </a:r>
+            <a:r>
+              <a:rPr sz="1700" b="0" i="0" dirty="0">
+                <a:solidFill>
+                  <a:srgbClr val="323232"/>
+                </a:solidFill>
+                <a:latin typeface="Calibri"/>
+              </a:rPr>
+              <a:t> tokenization with a sequence length of 512 tokens.</a:t>
+            </a:r>
+          </a:p>
+          <a:p>
+            <a:pPr marL="0" indent="0" algn="just">
               <a:spcAft>
                 <a:spcPts val="500"/>
               </a:spcAft>
+              <a:buNone/>
             </a:pPr>
             <a:r>
-              <a:rPr sz="1800" b="1" i="0">
-                <a:solidFill>
-                  <a:srgbClr val="323232"/>
+              <a:rPr sz="1700" b="1" i="0" dirty="0">
+                <a:solidFill>
+                  <a:srgbClr val="102C57"/>
                 </a:solidFill>
                 <a:latin typeface="Calibri"/>
               </a:rPr>
-              <a:t>• Macro-Averaged Precision: </a:t>
-            </a:r>
-            <a:r>
-              <a:rPr sz="1800" b="1" i="0">
-                <a:solidFill>
-                  <a:srgbClr val="102C57"/>
+              <a:t>• Stage 2: Contextual Representation Extraction: </a:t>
+            </a:r>
+            <a:r>
+              <a:rPr sz="1700" b="0" i="0" dirty="0">
+                <a:solidFill>
+                  <a:srgbClr val="323232"/>
                 </a:solidFill>
                 <a:latin typeface="Calibri"/>
               </a:rPr>
-              <a:t>94.0% (0.94) </a:t>
-            </a:r>
-            <a:r>
-              <a:rPr sz="1600" b="0" i="1">
-                <a:solidFill>
-                  <a:srgbClr val="505050"/>
-                </a:solidFill>
-                <a:latin typeface="Calibri"/>
-              </a:rPr>
-              <a:t>(High precision ensures minimal false alarms for legitimate employers.)</a:t>
-            </a:r>
-          </a:p>
-          <a:p>
-            <a:pPr>
+              <a:t>Passing token IDs through 12 transformer encoder blocks to generate 768-dimensional bidirectional contextual embeddings.</a:t>
+            </a:r>
+          </a:p>
+          <a:p>
+            <a:pPr marL="0" indent="0" algn="just">
               <a:spcAft>
                 <a:spcPts val="500"/>
               </a:spcAft>
+              <a:buNone/>
             </a:pPr>
             <a:r>
-              <a:rPr sz="1800" b="1" i="0">
-                <a:solidFill>
-                  <a:srgbClr val="323232"/>
+              <a:rPr sz="1700" b="1" i="0" dirty="0">
+                <a:solidFill>
+                  <a:srgbClr val="102C57"/>
                 </a:solidFill>
                 <a:latin typeface="Calibri"/>
               </a:rPr>
-              <a:t>• Macro-Averaged Recall: </a:t>
-            </a:r>
-            <a:r>
-              <a:rPr sz="1800" b="1" i="0">
-                <a:solidFill>
-                  <a:srgbClr val="102C57"/>
+              <a:t>• Stage 3: Model Fine-Tuning &amp; Optimization: </a:t>
+            </a:r>
+            <a:r>
+              <a:rPr sz="1700" b="0" i="0" dirty="0">
+                <a:solidFill>
+                  <a:srgbClr val="323232"/>
                 </a:solidFill>
                 <a:latin typeface="Calibri"/>
               </a:rPr>
-              <a:t>92.0% (0.92) </a:t>
-            </a:r>
-            <a:r>
-              <a:rPr sz="1600" b="0" i="1">
-                <a:solidFill>
-                  <a:srgbClr val="505050"/>
+              <a:t>Fine-tuning Fraud-BERT end-to-end using the </a:t>
+            </a:r>
+            <a:r>
+              <a:rPr sz="1700" b="0" i="0" dirty="0" err="1">
+                <a:solidFill>
+                  <a:srgbClr val="323232"/>
                 </a:solidFill>
                 <a:latin typeface="Calibri"/>
               </a:rPr>
-              <a:t>(Detects over 92% of fraudulent listings despite extreme class sparsity.)</a:t>
-            </a:r>
-          </a:p>
-          <a:p>
-            <a:pPr>
+              <a:t>AdamW</a:t>
+            </a:r>
+            <a:r>
+              <a:rPr sz="1700" b="0" i="0" dirty="0">
+                <a:solidFill>
+                  <a:srgbClr val="323232"/>
+                </a:solidFill>
+                <a:latin typeface="Calibri"/>
+              </a:rPr>
+              <a:t> optimizer with weight decay, linear warmup, and binary cross-entropy loss.</a:t>
+            </a:r>
+          </a:p>
+          <a:p>
+            <a:pPr marL="0" indent="0" algn="just">
               <a:spcAft>
                 <a:spcPts val="500"/>
               </a:spcAft>
+              <a:buNone/>
             </a:pPr>
             <a:r>
-              <a:rPr sz="1800" b="1" i="0">
-                <a:solidFill>
-                  <a:srgbClr val="323232"/>
+              <a:rPr sz="1700" b="1" i="0" dirty="0">
+                <a:solidFill>
+                  <a:srgbClr val="102C57"/>
                 </a:solidFill>
                 <a:latin typeface="Calibri"/>
               </a:rPr>
-              <a:t>• Macro-Averaged F1-Score: </a:t>
-            </a:r>
-            <a:r>
-              <a:rPr sz="1800" b="1" i="0">
-                <a:solidFill>
-                  <a:srgbClr val="102C57"/>
+              <a:t>• Stage 4: Prediction &amp; Classification Inference: </a:t>
+            </a:r>
+            <a:r>
+              <a:rPr sz="1700" b="0" i="0" dirty="0">
+                <a:solidFill>
+                  <a:srgbClr val="323232"/>
                 </a:solidFill>
                 <a:latin typeface="Calibri"/>
               </a:rPr>
-              <a:t>93.0% (0.93) </a:t>
-            </a:r>
-            <a:r>
-              <a:rPr sz="1600" b="0" i="1">
-                <a:solidFill>
-                  <a:srgbClr val="505050"/>
-                </a:solidFill>
-                <a:latin typeface="Calibri"/>
-              </a:rPr>
-              <a:t>(Balanced harmonic performance across both majority and minority classes.)</a:t>
-            </a:r>
-          </a:p>
-          <a:p>
-            <a:pPr>
+              <a:t>Extracting the [CLS] special token vector and projecting through a dense classification head to output class probabilities (0 = Legitimate, 1 = Fraudulent).</a:t>
+            </a:r>
+          </a:p>
+          <a:p>
+            <a:pPr marL="0" indent="0" algn="just">
               <a:spcAft>
                 <a:spcPts val="500"/>
               </a:spcAft>
+              <a:buNone/>
             </a:pPr>
             <a:r>
-              <a:rPr sz="1800" b="1" i="0">
-                <a:solidFill>
-                  <a:srgbClr val="323232"/>
+              <a:rPr sz="1700" b="1" i="0" dirty="0">
+                <a:solidFill>
+                  <a:srgbClr val="102C57"/>
                 </a:solidFill>
                 <a:latin typeface="Calibri"/>
               </a:rPr>
-              <a:t>• ROC-AUC Score: </a:t>
-            </a:r>
-            <a:r>
-              <a:rPr sz="1800" b="1" i="0">
-                <a:solidFill>
-                  <a:srgbClr val="102C57"/>
+              <a:t>• Stage 5: Multi-Metric Performance Evaluation: </a:t>
+            </a:r>
+            <a:r>
+              <a:rPr sz="1700" b="0" i="0" dirty="0">
+                <a:solidFill>
+                  <a:srgbClr val="323232"/>
                 </a:solidFill>
                 <a:latin typeface="Calibri"/>
               </a:rPr>
-              <a:t>0.99 </a:t>
-            </a:r>
-            <a:r>
-              <a:rPr sz="1600" b="0" i="1">
-                <a:solidFill>
-                  <a:srgbClr val="505050"/>
+              <a:t>Comprehensive evaluation using Accuracy, Macro Precision, Macro Recall, Macro F1-Score, and ROC-AUC metrics.</a:t>
+            </a:r>
+          </a:p>
+        </p:txBody>
+      </p:sp>
+      <p:sp>
+        <p:nvSpPr>
+          <p:cNvPr id="4" name="Slide Number Placeholder 3"/>
+          <p:cNvSpPr>
+            <a:spLocks noGrp="1"/>
+          </p:cNvSpPr>
+          <p:nvPr>
+            <p:ph type="sldNum" sz="quarter" idx="12"/>
+          </p:nvPr>
+        </p:nvSpPr>
+        <p:spPr/>
+        <p:txBody>
+          <a:bodyPr/>
+          <a:lstStyle/>
+          <a:p>
+            <a:pPr algn="r"/>
+            <a:r>
+              <a:rPr sz="1200" b="0" i="0">
+                <a:solidFill>
+                  <a:srgbClr val="787878"/>
                 </a:solidFill>
                 <a:latin typeface="Calibri"/>
               </a:rPr>
-              <a:t>(Demonstrates exceptional discrimination capability between genuine and fake posts.)</a:t>
-            </a:r>
-          </a:p>
-          <a:p>
-            <a:pPr>
-              <a:spcBef>
-                <a:spcPts val="800"/>
-              </a:spcBef>
-            </a:pPr>
-            <a:r>
-              <a:rPr sz="1800" b="1" i="0">
-                <a:solidFill>
-                  <a:srgbClr val="102C57"/>
-                </a:solidFill>
-                <a:latin typeface="Calibri"/>
-              </a:rPr>
-              <a:t>Comparative Conclusion: </a:t>
-            </a:r>
-            <a:r>
-              <a:rPr sz="1700" b="0" i="0">
-                <a:solidFill>
-                  <a:srgbClr val="323232"/>
-                </a:solidFill>
-                <a:latin typeface="Calibri"/>
-              </a:rPr>
-              <a:t>Fraud-BERT decisively outperforms traditional ML models (Logistic Regression F1: 0.86, Random Forest F1: 0.85) and static Bi-LSTM (AUC: 0.88) by capturing deep bidirectional linguistic context across complex recruitment scams.</a:t>
-            </a:r>
-          </a:p>
-        </p:txBody>
-      </p:sp>
-      <p:sp>
-        <p:nvSpPr>
-          <p:cNvPr id="4" name="Slide Number Placeholder 3"/>
-          <p:cNvSpPr>
-            <a:spLocks noGrp="1"/>
-          </p:cNvSpPr>
-          <p:nvPr>
-            <p:ph type="sldNum" sz="quarter" idx="12"/>
-          </p:nvPr>
-        </p:nvSpPr>
-        <p:spPr/>
-        <p:txBody>
-          <a:bodyPr/>
-          <a:lstStyle/>
-          <a:p>
-            <a:pPr algn="r"/>
-            <a:r>
-              <a:rPr sz="1200" b="0" i="0">
-                <a:solidFill>
-                  <a:srgbClr val="787878"/>
-                </a:solidFill>
-                <a:latin typeface="Calibri"/>
-              </a:rPr>
-              <a:t>9</a:t>
+              <a:t>7</a:t>
             </a:r>
           </a:p>
         </p:txBody>
@@ -16337,7 +16737,7 @@
     </p:spTree>
     <p:extLst>
       <p:ext uri="{BB962C8B-B14F-4D97-AF65-F5344CB8AC3E}">
-        <p14:creationId xmlns:p14="http://schemas.microsoft.com/office/powerpoint/2010/main" val="2987139833"/>
+        <p14:creationId xmlns:p14="http://schemas.microsoft.com/office/powerpoint/2010/main" val="588085132"/>
       </p:ext>
     </p:extLst>
   </p:cSld>
@@ -16378,13 +16778,7 @@
       </p:grpSpPr>
       <p:sp>
         <p:nvSpPr>
-          <p:cNvPr id="2" name="Title 1">
-            <a:extLst>
-              <a:ext uri="{FF2B5EF4-FFF2-40B4-BE49-F238E27FC236}">
-                <a16:creationId xmlns:a16="http://schemas.microsoft.com/office/drawing/2014/main" id="{636E7A3C-C78E-3208-1872-119F59D69BA3}"/>
-              </a:ext>
-            </a:extLst>
-          </p:cNvPr>
+          <p:cNvPr id="2" name="Title 1"/>
           <p:cNvSpPr>
             <a:spLocks noGrp="1"/>
           </p:cNvSpPr>
@@ -16394,48 +16788,8 @@
         </p:nvSpPr>
         <p:spPr>
           <a:xfrm>
-            <a:off x="838200" y="365125"/>
-            <a:ext cx="10515600" cy="690677"/>
-          </a:xfrm>
-        </p:spPr>
-        <p:txBody>
-          <a:bodyPr>
-            <a:normAutofit fontScale="90000"/>
-          </a:bodyPr>
-          <a:lstStyle/>
-          <a:p>
-            <a:r>
-              <a:rPr sz="3600" b="1" i="0">
-                <a:solidFill>
-                  <a:srgbClr val="102C57"/>
-                </a:solidFill>
-                <a:latin typeface="Calibri"/>
-              </a:rPr>
-              <a:t>Bibliography or References</a:t>
-            </a:r>
-          </a:p>
-        </p:txBody>
-      </p:sp>
-      <p:sp>
-        <p:nvSpPr>
-          <p:cNvPr id="3" name="Content Placeholder 2">
-            <a:extLst>
-              <a:ext uri="{FF2B5EF4-FFF2-40B4-BE49-F238E27FC236}">
-                <a16:creationId xmlns:a16="http://schemas.microsoft.com/office/drawing/2014/main" id="{5C3A669F-24DE-9251-47BD-73C228B1EC1C}"/>
-              </a:ext>
-            </a:extLst>
-          </p:cNvPr>
-          <p:cNvSpPr>
-            <a:spLocks noGrp="1"/>
-          </p:cNvSpPr>
-          <p:nvPr>
-            <p:ph idx="1"/>
-          </p:nvPr>
-        </p:nvSpPr>
-        <p:spPr>
-          <a:xfrm>
-            <a:off x="838200" y="1354283"/>
-            <a:ext cx="10515600" cy="5138591"/>
+            <a:off x="838200" y="299138"/>
+            <a:ext cx="6404429" cy="926645"/>
           </a:xfrm>
         </p:spPr>
         <p:txBody>
@@ -16443,404 +16797,284 @@
             <a:normAutofit/>
           </a:bodyPr>
           <a:lstStyle/>
-          <a:p/>
-          <a:p>
-            <a:pPr>
-              <a:lnSpc>
-                <a:spcPct val="115000"/>
-              </a:lnSpc>
+          <a:p>
+            <a:r>
+              <a:rPr sz="3600" b="1" i="0">
+                <a:solidFill>
+                  <a:srgbClr val="102C57"/>
+                </a:solidFill>
+                <a:latin typeface="Calibri"/>
+              </a:rPr>
+              <a:t>Results &amp; Performance Analysis</a:t>
+            </a:r>
+          </a:p>
+        </p:txBody>
+      </p:sp>
+      <p:sp>
+        <p:nvSpPr>
+          <p:cNvPr id="3" name="Content Placeholder 2"/>
+          <p:cNvSpPr>
+            <a:spLocks noGrp="1"/>
+          </p:cNvSpPr>
+          <p:nvPr>
+            <p:ph idx="1"/>
+          </p:nvPr>
+        </p:nvSpPr>
+        <p:spPr>
+          <a:xfrm>
+            <a:off x="838200" y="1582057"/>
+            <a:ext cx="10515600" cy="4594906"/>
+          </a:xfrm>
+        </p:spPr>
+        <p:txBody>
+          <a:bodyPr>
+            <a:normAutofit/>
+          </a:bodyPr>
+          <a:lstStyle/>
+          <a:p>
+            <a:pPr marL="0" indent="0">
               <a:spcAft>
                 <a:spcPts val="800"/>
               </a:spcAft>
+              <a:buNone/>
             </a:pPr>
             <a:r>
-              <a:rPr sz="1300" b="1" i="0">
+              <a:rPr sz="2000" b="1" i="0" dirty="0">
                 <a:solidFill>
                   <a:srgbClr val="102C57"/>
                 </a:solidFill>
                 <a:latin typeface="Calibri"/>
               </a:rPr>
-              <a:t>[1] </a:t>
-            </a:r>
-            <a:r>
-              <a:rPr sz="1300" b="0" i="0">
+              <a:t>Fraud-BERT achieved state-of-the-art results on the EMSCAD benchmark:</a:t>
+            </a:r>
+          </a:p>
+          <a:p>
+            <a:pPr marL="0" indent="0">
+              <a:spcAft>
+                <a:spcPts val="500"/>
+              </a:spcAft>
+              <a:buNone/>
+            </a:pPr>
+            <a:r>
+              <a:rPr sz="1800" b="1" i="0" dirty="0">
                 <a:solidFill>
                   <a:srgbClr val="323232"/>
                 </a:solidFill>
                 <a:latin typeface="Calibri"/>
               </a:rPr>
-              <a:t>Taneja, K., Vashishtha, J., &amp; Ratnoo, S. (2025). Fraud-BERT: Transformer based context aware online recruitment fraud detection. </a:t>
-            </a:r>
-            <a:r>
-              <a:rPr sz="1300" b="0" i="1">
-                <a:solidFill>
-                  <a:srgbClr val="323232"/>
+              <a:t>• Overall Classification Accuracy: </a:t>
+            </a:r>
+            <a:r>
+              <a:rPr sz="1800" b="1" i="0" dirty="0">
+                <a:solidFill>
+                  <a:srgbClr val="102C57"/>
                 </a:solidFill>
                 <a:latin typeface="Calibri"/>
               </a:rPr>
-              <a:t>Discover Computing</a:t>
-            </a:r>
-            <a:r>
-              <a:rPr sz="1300" b="0" i="0">
-                <a:solidFill>
-                  <a:srgbClr val="323232"/>
+              <a:t>99.0% (0.99) </a:t>
+            </a:r>
+            <a:r>
+              <a:rPr sz="1600" b="0" i="1" dirty="0">
+                <a:solidFill>
+                  <a:srgbClr val="505050"/>
                 </a:solidFill>
                 <a:latin typeface="Calibri"/>
               </a:rPr>
-              <a:t>, </a:t>
-            </a:r>
-            <a:r>
-              <a:rPr sz="1300" b="0" i="1">
+              <a:t>(Near-flawless classification across the complete test partition.)</a:t>
+            </a:r>
+          </a:p>
+          <a:p>
+            <a:pPr marL="0" indent="0">
+              <a:spcAft>
+                <a:spcPts val="500"/>
+              </a:spcAft>
+              <a:buNone/>
+            </a:pPr>
+            <a:r>
+              <a:rPr sz="1800" b="1" i="0" dirty="0">
                 <a:solidFill>
                   <a:srgbClr val="323232"/>
                 </a:solidFill>
                 <a:latin typeface="Calibri"/>
               </a:rPr>
-              <a:t>28</a:t>
-            </a:r>
-            <a:r>
-              <a:rPr sz="1300" b="0" i="0">
-                <a:solidFill>
-                  <a:srgbClr val="323232"/>
+              <a:t>• Macro-Averaged Precision: </a:t>
+            </a:r>
+            <a:r>
+              <a:rPr sz="1800" b="1" i="0" dirty="0">
+                <a:solidFill>
+                  <a:srgbClr val="102C57"/>
                 </a:solidFill>
                 <a:latin typeface="Calibri"/>
               </a:rPr>
-              <a:t>(9), 1–16.</a:t>
-            </a:r>
-            <a:r>
-              <a:rPr sz="1200" b="0" i="0">
-                <a:solidFill>
-                  <a:srgbClr val="0066CC"/>
+              <a:t>94.0% (0.94) </a:t>
+            </a:r>
+            <a:r>
+              <a:rPr sz="1600" b="0" i="1" dirty="0">
+                <a:solidFill>
+                  <a:srgbClr val="505050"/>
                 </a:solidFill>
                 <a:latin typeface="Calibri"/>
               </a:rPr>
-              <a:t> https://doi.org/10.1007/s44425-025-00109-x</a:t>
-            </a:r>
-          </a:p>
-          <a:p>
-            <a:pPr>
-              <a:lnSpc>
-                <a:spcPct val="115000"/>
-              </a:lnSpc>
+              <a:t>(High precision ensures minimal false alarms for legitimate employers.)</a:t>
+            </a:r>
+          </a:p>
+          <a:p>
+            <a:pPr marL="0" indent="0">
               <a:spcAft>
-                <a:spcPts val="800"/>
+                <a:spcPts val="500"/>
               </a:spcAft>
+              <a:buNone/>
             </a:pPr>
             <a:r>
-              <a:rPr sz="1300" b="1" i="0">
-                <a:solidFill>
-                  <a:srgbClr val="102C57"/>
+              <a:rPr sz="1800" b="1" i="0" dirty="0">
+                <a:solidFill>
+                  <a:srgbClr val="323232"/>
                 </a:solidFill>
                 <a:latin typeface="Calibri"/>
               </a:rPr>
-              <a:t>[2] </a:t>
-            </a:r>
-            <a:r>
-              <a:rPr sz="1300" b="0" i="0">
-                <a:solidFill>
-                  <a:srgbClr val="323232"/>
+              <a:t>• Macro-Averaged Recall: </a:t>
+            </a:r>
+            <a:r>
+              <a:rPr sz="1800" b="1" i="0" dirty="0">
+                <a:solidFill>
+                  <a:srgbClr val="102C57"/>
                 </a:solidFill>
                 <a:latin typeface="Calibri"/>
               </a:rPr>
-              <a:t>Pillai, A. S. (2023). Detecting fake job postings using bidirectional LSTM. </a:t>
-            </a:r>
-            <a:r>
-              <a:rPr sz="1300" b="0" i="1">
-                <a:solidFill>
-                  <a:srgbClr val="323232"/>
+              <a:t>92.0% (0.92) </a:t>
+            </a:r>
+            <a:r>
+              <a:rPr sz="1600" b="0" i="1" dirty="0">
+                <a:solidFill>
+                  <a:srgbClr val="505050"/>
                 </a:solidFill>
                 <a:latin typeface="Calibri"/>
               </a:rPr>
-              <a:t>International Research Journal of Modernization in Engineering Technology and Science</a:t>
-            </a:r>
-            <a:r>
-              <a:rPr sz="1300" b="0" i="0">
+              <a:t>(Detects over 92% of fraudulent listings despite extreme class sparsity.)</a:t>
+            </a:r>
+          </a:p>
+          <a:p>
+            <a:pPr marL="0" indent="0">
+              <a:spcAft>
+                <a:spcPts val="500"/>
+              </a:spcAft>
+              <a:buNone/>
+            </a:pPr>
+            <a:r>
+              <a:rPr sz="1800" b="1" i="0" dirty="0">
                 <a:solidFill>
                   <a:srgbClr val="323232"/>
                 </a:solidFill>
                 <a:latin typeface="Calibri"/>
               </a:rPr>
-              <a:t>, </a:t>
-            </a:r>
-            <a:r>
-              <a:rPr sz="1300" b="0" i="1">
-                <a:solidFill>
-                  <a:srgbClr val="323232"/>
+              <a:t>• Macro-Averaged F1-Score: </a:t>
+            </a:r>
+            <a:r>
+              <a:rPr sz="1800" b="1" i="0" dirty="0">
+                <a:solidFill>
+                  <a:srgbClr val="102C57"/>
                 </a:solidFill>
                 <a:latin typeface="Calibri"/>
               </a:rPr>
-              <a:t>5</a:t>
-            </a:r>
-            <a:r>
-              <a:rPr sz="1300" b="0" i="0">
-                <a:solidFill>
-                  <a:srgbClr val="323232"/>
+              <a:t>93.0% (0.93) </a:t>
+            </a:r>
+            <a:r>
+              <a:rPr sz="1600" b="0" i="1" dirty="0">
+                <a:solidFill>
+                  <a:srgbClr val="505050"/>
                 </a:solidFill>
                 <a:latin typeface="Calibri"/>
               </a:rPr>
-              <a:t>(3), 3883–3890.</a:t>
-            </a:r>
-            <a:r>
-              <a:rPr sz="1200" b="0" i="0">
-                <a:solidFill>
-                  <a:srgbClr val="0066CC"/>
+              <a:t>(Balanced harmonic performance across both majority and minority classes.)</a:t>
+            </a:r>
+          </a:p>
+          <a:p>
+            <a:pPr marL="0" indent="0">
+              <a:spcAft>
+                <a:spcPts val="500"/>
+              </a:spcAft>
+              <a:buNone/>
+            </a:pPr>
+            <a:r>
+              <a:rPr sz="1800" b="1" i="0" dirty="0">
+                <a:solidFill>
+                  <a:srgbClr val="323232"/>
                 </a:solidFill>
                 <a:latin typeface="Calibri"/>
               </a:rPr>
-              <a:t> https://doi.org/10.56726/IRJMETS34628</a:t>
-            </a:r>
-          </a:p>
-          <a:p>
-            <a:pPr>
-              <a:lnSpc>
-                <a:spcPct val="115000"/>
-              </a:lnSpc>
-              <a:spcAft>
-                <a:spcPts val="800"/>
-              </a:spcAft>
-            </a:pPr>
-            <a:r>
-              <a:rPr sz="1300" b="1" i="0">
+              <a:t>• ROC-AUC Score: </a:t>
+            </a:r>
+            <a:r>
+              <a:rPr sz="1800" b="1" i="0" dirty="0">
                 <a:solidFill>
                   <a:srgbClr val="102C57"/>
                 </a:solidFill>
                 <a:latin typeface="Calibri"/>
               </a:rPr>
-              <a:t>[3] </a:t>
-            </a:r>
-            <a:r>
-              <a:rPr sz="1300" b="0" i="0">
-                <a:solidFill>
-                  <a:srgbClr val="323232"/>
+              <a:t>0.99 </a:t>
+            </a:r>
+            <a:r>
+              <a:rPr sz="1600" b="0" i="1" dirty="0">
+                <a:solidFill>
+                  <a:srgbClr val="505050"/>
                 </a:solidFill>
                 <a:latin typeface="Calibri"/>
               </a:rPr>
-              <a:t>Naudé, M., Adebayo, K. J., &amp; Nanda, R. (2023). A machine learning approach to detecting fraudulent job types. </a:t>
-            </a:r>
-            <a:r>
-              <a:rPr sz="1300" b="0" i="1">
-                <a:solidFill>
-                  <a:srgbClr val="323232"/>
+              <a:t>(Demonstrates exceptional discrimination capability between genuine and fake posts.)</a:t>
+            </a:r>
+          </a:p>
+          <a:p>
+            <a:pPr marL="0" indent="0">
+              <a:spcBef>
+                <a:spcPts val="800"/>
+              </a:spcBef>
+              <a:buNone/>
+            </a:pPr>
+            <a:r>
+              <a:rPr sz="1800" b="1" i="0" dirty="0">
+                <a:solidFill>
+                  <a:srgbClr val="102C57"/>
                 </a:solidFill>
                 <a:latin typeface="Calibri"/>
               </a:rPr>
-              <a:t>AI &amp; SOCIETY</a:t>
-            </a:r>
-            <a:r>
-              <a:rPr sz="1300" b="0" i="0">
+              <a:t>Comparative Conclusion: </a:t>
+            </a:r>
+            <a:r>
+              <a:rPr sz="1700" b="0" i="0" dirty="0">
                 <a:solidFill>
                   <a:srgbClr val="323232"/>
                 </a:solidFill>
                 <a:latin typeface="Calibri"/>
               </a:rPr>
-              <a:t>, </a:t>
-            </a:r>
-            <a:r>
-              <a:rPr sz="1300" b="0" i="1">
-                <a:solidFill>
-                  <a:srgbClr val="323232"/>
+              <a:t>Fraud-BERT decisively outperforms traditional ML models (Logistic Regression F1: 0.86, Random Forest F1: 0.85) and static Bi-LSTM (AUC: 0.88) by capturing deep bidirectional linguistic context across complex recruitment scams.</a:t>
+            </a:r>
+          </a:p>
+        </p:txBody>
+      </p:sp>
+      <p:sp>
+        <p:nvSpPr>
+          <p:cNvPr id="4" name="Slide Number Placeholder 3"/>
+          <p:cNvSpPr>
+            <a:spLocks noGrp="1"/>
+          </p:cNvSpPr>
+          <p:nvPr>
+            <p:ph type="sldNum" sz="quarter" idx="12"/>
+          </p:nvPr>
+        </p:nvSpPr>
+        <p:spPr/>
+        <p:txBody>
+          <a:bodyPr/>
+          <a:lstStyle/>
+          <a:p>
+            <a:pPr algn="r"/>
+            <a:r>
+              <a:rPr sz="1200" b="0" i="0">
+                <a:solidFill>
+                  <a:srgbClr val="787878"/>
                 </a:solidFill>
                 <a:latin typeface="Calibri"/>
               </a:rPr>
-              <a:t>38</a:t>
-            </a:r>
-            <a:r>
-              <a:rPr sz="1300" b="0" i="0">
-                <a:solidFill>
-                  <a:srgbClr val="323232"/>
-                </a:solidFill>
-                <a:latin typeface="Calibri"/>
-              </a:rPr>
-              <a:t>(3), 1013–1024.</a:t>
-            </a:r>
-            <a:r>
-              <a:rPr sz="1200" b="0" i="0">
-                <a:solidFill>
-                  <a:srgbClr val="0066CC"/>
-                </a:solidFill>
-                <a:latin typeface="Calibri"/>
-              </a:rPr>
-              <a:t> https://doi.org/10.1007/s00146-021-01314-z</a:t>
-            </a:r>
-          </a:p>
-          <a:p>
-            <a:pPr>
-              <a:lnSpc>
-                <a:spcPct val="115000"/>
-              </a:lnSpc>
-              <a:spcAft>
-                <a:spcPts val="800"/>
-              </a:spcAft>
-            </a:pPr>
-            <a:r>
-              <a:rPr sz="1300" b="1" i="0">
-                <a:solidFill>
-                  <a:srgbClr val="102C57"/>
-                </a:solidFill>
-                <a:latin typeface="Calibri"/>
-              </a:rPr>
-              <a:t>[4] </a:t>
-            </a:r>
-            <a:r>
-              <a:rPr sz="1300" b="0" i="0">
-                <a:solidFill>
-                  <a:srgbClr val="323232"/>
-                </a:solidFill>
-                <a:latin typeface="Calibri"/>
-              </a:rPr>
-              <a:t>Chiraratanasopha, B., &amp; Chay-intr, T. (2022). Detecting fraud job recruitment using features reflecting from real-world knowledge of fraud. </a:t>
-            </a:r>
-            <a:r>
-              <a:rPr sz="1300" b="0" i="1">
-                <a:solidFill>
-                  <a:srgbClr val="323232"/>
-                </a:solidFill>
-                <a:latin typeface="Calibri"/>
-              </a:rPr>
-              <a:t>Current Applied Science and Technology</a:t>
-            </a:r>
-            <a:r>
-              <a:rPr sz="1300" b="0" i="0">
-                <a:solidFill>
-                  <a:srgbClr val="323232"/>
-                </a:solidFill>
-                <a:latin typeface="Calibri"/>
-              </a:rPr>
-              <a:t>, </a:t>
-            </a:r>
-            <a:r>
-              <a:rPr sz="1300" b="0" i="1">
-                <a:solidFill>
-                  <a:srgbClr val="323232"/>
-                </a:solidFill>
-                <a:latin typeface="Calibri"/>
-              </a:rPr>
-              <a:t>22</a:t>
-            </a:r>
-            <a:r>
-              <a:rPr sz="1300" b="0" i="0">
-                <a:solidFill>
-                  <a:srgbClr val="323232"/>
-                </a:solidFill>
-                <a:latin typeface="Calibri"/>
-              </a:rPr>
-              <a:t>(6), 1–12.</a:t>
-            </a:r>
-            <a:r>
-              <a:rPr sz="1200" b="0" i="0">
-                <a:solidFill>
-                  <a:srgbClr val="0066CC"/>
-                </a:solidFill>
-                <a:latin typeface="Calibri"/>
-              </a:rPr>
-              <a:t> https://doi.org/10.55003/cast.2022.06.22.015</a:t>
-            </a:r>
-          </a:p>
-          <a:p>
-            <a:pPr>
-              <a:lnSpc>
-                <a:spcPct val="115000"/>
-              </a:lnSpc>
-              <a:spcAft>
-                <a:spcPts val="800"/>
-              </a:spcAft>
-            </a:pPr>
-            <a:r>
-              <a:rPr sz="1300" b="1" i="0">
-                <a:solidFill>
-                  <a:srgbClr val="102C57"/>
-                </a:solidFill>
-                <a:latin typeface="Calibri"/>
-              </a:rPr>
-              <a:t>[5] </a:t>
-            </a:r>
-            <a:r>
-              <a:rPr sz="1300" b="0" i="0">
-                <a:solidFill>
-                  <a:srgbClr val="323232"/>
-                </a:solidFill>
-                <a:latin typeface="Calibri"/>
-              </a:rPr>
-              <a:t>Varshitha, G., Sowmya, K., Sheshma, K., Sowmya, K., &amp; Manikandan, R. A. (2026). Online recruitment fraud detection using deep learning approaches. </a:t>
-            </a:r>
-            <a:r>
-              <a:rPr sz="1300" b="0" i="1">
-                <a:solidFill>
-                  <a:srgbClr val="323232"/>
-                </a:solidFill>
-                <a:latin typeface="Calibri"/>
-              </a:rPr>
-              <a:t>International Journal for Multidisciplinary Research (IJFMR)</a:t>
-            </a:r>
-            <a:r>
-              <a:rPr sz="1300" b="0" i="0">
-                <a:solidFill>
-                  <a:srgbClr val="323232"/>
-                </a:solidFill>
-                <a:latin typeface="Calibri"/>
-              </a:rPr>
-              <a:t>, </a:t>
-            </a:r>
-            <a:r>
-              <a:rPr sz="1300" b="0" i="1">
-                <a:solidFill>
-                  <a:srgbClr val="323232"/>
-                </a:solidFill>
-                <a:latin typeface="Calibri"/>
-              </a:rPr>
-              <a:t>8</a:t>
-            </a:r>
-            <a:r>
-              <a:rPr sz="1300" b="0" i="0">
-                <a:solidFill>
-                  <a:srgbClr val="323232"/>
-                </a:solidFill>
-                <a:latin typeface="Calibri"/>
-              </a:rPr>
-              <a:t>(2), 1–9.</a:t>
-            </a:r>
-            <a:r>
-              <a:rPr sz="1200" b="0" i="0">
-                <a:solidFill>
-                  <a:srgbClr val="0066CC"/>
-                </a:solidFill>
-                <a:latin typeface="Calibri"/>
-              </a:rPr>
-              <a:t> https://doi.org/10.36948/ijfmr.2026.v08i02.14582</a:t>
-            </a:r>
-          </a:p>
-        </p:txBody>
-      </p:sp>
-      <p:sp>
-        <p:nvSpPr>
-          <p:cNvPr id="4" name="Slide Number Placeholder 3">
-            <a:extLst>
-              <a:ext uri="{FF2B5EF4-FFF2-40B4-BE49-F238E27FC236}">
-                <a16:creationId xmlns:a16="http://schemas.microsoft.com/office/drawing/2014/main" id="{904A35CC-DD65-AB1D-D9C1-30BD38C24B0B}"/>
-              </a:ext>
-            </a:extLst>
-          </p:cNvPr>
-          <p:cNvSpPr>
-            <a:spLocks noGrp="1"/>
-          </p:cNvSpPr>
-          <p:nvPr>
-            <p:ph type="sldNum" sz="quarter" idx="12"/>
-          </p:nvPr>
-        </p:nvSpPr>
-        <p:spPr/>
-        <p:txBody>
-          <a:bodyPr/>
-          <a:lstStyle/>
-          <a:p>
-            <a:pPr algn="r"/>
-            <a:r>
-              <a:rPr sz="1200" b="0" i="0">
-                <a:solidFill>
-                  <a:srgbClr val="787878"/>
-                </a:solidFill>
-                <a:latin typeface="Calibri"/>
-              </a:rPr>
-              <a:t>10</a:t>
+              <a:t>9</a:t>
             </a:r>
           </a:p>
         </p:txBody>
@@ -16848,7 +17082,7 @@
     </p:spTree>
     <p:extLst>
       <p:ext uri="{BB962C8B-B14F-4D97-AF65-F5344CB8AC3E}">
-        <p14:creationId xmlns:p14="http://schemas.microsoft.com/office/powerpoint/2010/main" val="526818776"/>
+        <p14:creationId xmlns:p14="http://schemas.microsoft.com/office/powerpoint/2010/main" val="2987139833"/>
       </p:ext>
     </p:extLst>
   </p:cSld>

</xml_diff>